<commit_message>
Added slide deck notes
</commit_message>
<xml_diff>
--- a/Capstone_2/Movies slide deck.pptx
+++ b/Capstone_2/Movies slide deck.pptx
@@ -4,6 +4,9 @@
   <p:sldMasterIdLst>
     <p:sldMasterId id="2147483648" r:id="rId1"/>
   </p:sldMasterIdLst>
+  <p:notesMasterIdLst>
+    <p:notesMasterId r:id="rId23"/>
+  </p:notesMasterIdLst>
   <p:sldIdLst>
     <p:sldId id="256" r:id="rId2"/>
     <p:sldId id="257" r:id="rId3"/>
@@ -124,6 +127,11 @@
       </a:defRPr>
     </a:lvl9pPr>
   </p:defaultTextStyle>
+  <p:extLst>
+    <p:ext uri="{EFAFB233-063F-42B5-8137-9DF3F51BA10A}">
+      <p15:sldGuideLst xmlns:p15="http://schemas.microsoft.com/office/powerpoint/2012/main"/>
+    </p:ext>
+  </p:extLst>
 </p:presentation>
 </file>
 
@@ -4476,7 +4484,7 @@
   <dgm:whole/>
   <dgm:extLst>
     <a:ext uri="http://schemas.microsoft.com/office/drawing/2008/diagram">
-      <dsp:dataModelExt xmlns:dsp="http://schemas.microsoft.com/office/drawing/2008/diagram" relId="rId6" minVer="http://schemas.openxmlformats.org/drawingml/2006/diagram"/>
+      <dsp:dataModelExt xmlns:dsp="http://schemas.microsoft.com/office/drawing/2008/diagram" relId="rId7" minVer="http://schemas.openxmlformats.org/drawingml/2006/diagram"/>
     </a:ext>
   </dgm:extLst>
 </dgm:dataModel>
@@ -4580,7 +4588,7 @@
         <a:lstStyle/>
         <a:p>
           <a:r>
-            <a:rPr lang="en-US"/>
+            <a:rPr lang="en-US" dirty="0"/>
             <a:t>Title</a:t>
           </a:r>
         </a:p>
@@ -4616,7 +4624,7 @@
         <a:lstStyle/>
         <a:p>
           <a:r>
-            <a:rPr lang="en-US"/>
+            <a:rPr lang="en-US" dirty="0"/>
             <a:t>Release dates</a:t>
           </a:r>
         </a:p>
@@ -4652,7 +4660,7 @@
         <a:lstStyle/>
         <a:p>
           <a:r>
-            <a:rPr lang="en-US"/>
+            <a:rPr lang="en-US" dirty="0"/>
             <a:t>Budget</a:t>
           </a:r>
         </a:p>
@@ -4724,7 +4732,7 @@
         <a:lstStyle/>
         <a:p>
           <a:r>
-            <a:rPr lang="en-US"/>
+            <a:rPr lang="en-US" dirty="0"/>
             <a:t>Genre</a:t>
           </a:r>
         </a:p>
@@ -4760,7 +4768,7 @@
         <a:lstStyle/>
         <a:p>
           <a:r>
-            <a:rPr lang="en-US"/>
+            <a:rPr lang="en-US" dirty="0"/>
             <a:t>Runtime</a:t>
           </a:r>
         </a:p>
@@ -4868,7 +4876,7 @@
         <a:lstStyle/>
         <a:p>
           <a:r>
-            <a:rPr lang="en-US"/>
+            <a:rPr lang="en-US" dirty="0"/>
             <a:t>Number of Reviews</a:t>
           </a:r>
         </a:p>
@@ -4965,7 +4973,7 @@
   <dgm:whole/>
   <dgm:extLst>
     <a:ext uri="http://schemas.microsoft.com/office/drawing/2008/diagram">
-      <dsp:dataModelExt xmlns:dsp="http://schemas.microsoft.com/office/drawing/2008/diagram" relId="rId6" minVer="http://schemas.openxmlformats.org/drawingml/2006/diagram"/>
+      <dsp:dataModelExt xmlns:dsp="http://schemas.microsoft.com/office/drawing/2008/diagram" relId="rId7" minVer="http://schemas.openxmlformats.org/drawingml/2006/diagram"/>
     </a:ext>
   </dgm:extLst>
 </dgm:dataModel>
@@ -5156,7 +5164,7 @@
   <dgm:whole/>
   <dgm:extLst>
     <a:ext uri="http://schemas.microsoft.com/office/drawing/2008/diagram">
-      <dsp:dataModelExt xmlns:dsp="http://schemas.microsoft.com/office/drawing/2008/diagram" relId="rId7" minVer="http://schemas.openxmlformats.org/drawingml/2006/diagram"/>
+      <dsp:dataModelExt xmlns:dsp="http://schemas.microsoft.com/office/drawing/2008/diagram" relId="rId8" minVer="http://schemas.openxmlformats.org/drawingml/2006/diagram"/>
     </a:ext>
   </dgm:extLst>
 </dgm:dataModel>
@@ -5408,7 +5416,7 @@
   <dgm:whole/>
   <dgm:extLst>
     <a:ext uri="http://schemas.microsoft.com/office/drawing/2008/diagram">
-      <dsp:dataModelExt xmlns:dsp="http://schemas.microsoft.com/office/drawing/2008/diagram" relId="rId6" minVer="http://schemas.openxmlformats.org/drawingml/2006/diagram"/>
+      <dsp:dataModelExt xmlns:dsp="http://schemas.microsoft.com/office/drawing/2008/diagram" relId="rId7" minVer="http://schemas.openxmlformats.org/drawingml/2006/diagram"/>
     </a:ext>
   </dgm:extLst>
 </dgm:dataModel>
@@ -5905,7 +5913,7 @@
   <dgm:whole/>
   <dgm:extLst>
     <a:ext uri="http://schemas.microsoft.com/office/drawing/2008/diagram">
-      <dsp:dataModelExt xmlns:dsp="http://schemas.microsoft.com/office/drawing/2008/diagram" relId="rId6" minVer="http://schemas.openxmlformats.org/drawingml/2006/diagram"/>
+      <dsp:dataModelExt xmlns:dsp="http://schemas.microsoft.com/office/drawing/2008/diagram" relId="rId7" minVer="http://schemas.openxmlformats.org/drawingml/2006/diagram"/>
     </a:ext>
   </dgm:extLst>
 </dgm:dataModel>
@@ -6562,7 +6570,7 @@
             <a:buChar char="•"/>
           </a:pPr>
           <a:r>
-            <a:rPr lang="en-US" sz="1800" kern="1200"/>
+            <a:rPr lang="en-US" sz="1800" kern="1200" dirty="0"/>
             <a:t>Title</a:t>
           </a:r>
         </a:p>
@@ -6580,7 +6588,7 @@
             <a:buChar char="•"/>
           </a:pPr>
           <a:r>
-            <a:rPr lang="en-US" sz="1800" kern="1200"/>
+            <a:rPr lang="en-US" sz="1800" kern="1200" dirty="0"/>
             <a:t>Release dates</a:t>
           </a:r>
         </a:p>
@@ -6598,7 +6606,7 @@
             <a:buChar char="•"/>
           </a:pPr>
           <a:r>
-            <a:rPr lang="en-US" sz="1800" kern="1200"/>
+            <a:rPr lang="en-US" sz="1800" kern="1200" dirty="0"/>
             <a:t>Budget</a:t>
           </a:r>
         </a:p>
@@ -6634,7 +6642,7 @@
             <a:buChar char="•"/>
           </a:pPr>
           <a:r>
-            <a:rPr lang="en-US" sz="1800" kern="1200"/>
+            <a:rPr lang="en-US" sz="1800" kern="1200" dirty="0"/>
             <a:t>Genre</a:t>
           </a:r>
         </a:p>
@@ -6652,7 +6660,7 @@
             <a:buChar char="•"/>
           </a:pPr>
           <a:r>
-            <a:rPr lang="en-US" sz="1800" kern="1200"/>
+            <a:rPr lang="en-US" sz="1800" kern="1200" dirty="0"/>
             <a:t>Runtime</a:t>
           </a:r>
         </a:p>
@@ -6706,7 +6714,7 @@
             <a:buChar char="•"/>
           </a:pPr>
           <a:r>
-            <a:rPr lang="en-US" sz="1800" kern="1200"/>
+            <a:rPr lang="en-US" sz="1800" kern="1200" dirty="0"/>
             <a:t>Number of Reviews</a:t>
           </a:r>
         </a:p>
@@ -15379,6 +15387,2253 @@
 </dgm:styleDef>
 </file>
 
+<file path=ppt/notesMasters/notesMaster1.xml><?xml version="1.0" encoding="utf-8"?>
+<p:notesMaster xmlns:a="http://schemas.openxmlformats.org/drawingml/2006/main" xmlns:r="http://schemas.openxmlformats.org/officeDocument/2006/relationships" xmlns:p="http://schemas.openxmlformats.org/presentationml/2006/main">
+  <p:cSld>
+    <p:bg>
+      <p:bgRef idx="1001">
+        <a:schemeClr val="bg1"/>
+      </p:bgRef>
+    </p:bg>
+    <p:spTree>
+      <p:nvGrpSpPr>
+        <p:cNvPr id="1" name=""/>
+        <p:cNvGrpSpPr/>
+        <p:nvPr/>
+      </p:nvGrpSpPr>
+      <p:grpSpPr>
+        <a:xfrm>
+          <a:off x="0" y="0"/>
+          <a:ext cx="0" cy="0"/>
+          <a:chOff x="0" y="0"/>
+          <a:chExt cx="0" cy="0"/>
+        </a:xfrm>
+      </p:grpSpPr>
+      <p:sp>
+        <p:nvSpPr>
+          <p:cNvPr id="2" name="Header Placeholder 1"/>
+          <p:cNvSpPr>
+            <a:spLocks noGrp="1"/>
+          </p:cNvSpPr>
+          <p:nvPr>
+            <p:ph type="hdr" sz="quarter"/>
+          </p:nvPr>
+        </p:nvSpPr>
+        <p:spPr>
+          <a:xfrm>
+            <a:off x="0" y="0"/>
+            <a:ext cx="2971800" cy="458788"/>
+          </a:xfrm>
+          <a:prstGeom prst="rect">
+            <a:avLst/>
+          </a:prstGeom>
+        </p:spPr>
+        <p:txBody>
+          <a:bodyPr vert="horz" lIns="91440" tIns="45720" rIns="91440" bIns="45720" rtlCol="0"/>
+          <a:lstStyle>
+            <a:lvl1pPr algn="l">
+              <a:defRPr sz="1200"/>
+            </a:lvl1pPr>
+          </a:lstStyle>
+          <a:p>
+            <a:endParaRPr lang="en-US"/>
+          </a:p>
+        </p:txBody>
+      </p:sp>
+      <p:sp>
+        <p:nvSpPr>
+          <p:cNvPr id="3" name="Date Placeholder 2"/>
+          <p:cNvSpPr>
+            <a:spLocks noGrp="1"/>
+          </p:cNvSpPr>
+          <p:nvPr>
+            <p:ph type="dt" idx="1"/>
+          </p:nvPr>
+        </p:nvSpPr>
+        <p:spPr>
+          <a:xfrm>
+            <a:off x="3884613" y="0"/>
+            <a:ext cx="2971800" cy="458788"/>
+          </a:xfrm>
+          <a:prstGeom prst="rect">
+            <a:avLst/>
+          </a:prstGeom>
+        </p:spPr>
+        <p:txBody>
+          <a:bodyPr vert="horz" lIns="91440" tIns="45720" rIns="91440" bIns="45720" rtlCol="0"/>
+          <a:lstStyle>
+            <a:lvl1pPr algn="r">
+              <a:defRPr sz="1200"/>
+            </a:lvl1pPr>
+          </a:lstStyle>
+          <a:p>
+            <a:fld id="{CE56E6BB-C564-40CB-988E-4AF30F4FDC95}" type="datetimeFigureOut">
+              <a:rPr lang="en-US" smtClean="0"/>
+              <a:t>8/28/2025</a:t>
+            </a:fld>
+            <a:endParaRPr lang="en-US"/>
+          </a:p>
+        </p:txBody>
+      </p:sp>
+      <p:sp>
+        <p:nvSpPr>
+          <p:cNvPr id="4" name="Slide Image Placeholder 3"/>
+          <p:cNvSpPr>
+            <a:spLocks noGrp="1" noRot="1" noChangeAspect="1"/>
+          </p:cNvSpPr>
+          <p:nvPr>
+            <p:ph type="sldImg" idx="2"/>
+          </p:nvPr>
+        </p:nvSpPr>
+        <p:spPr>
+          <a:xfrm>
+            <a:off x="685800" y="1143000"/>
+            <a:ext cx="5486400" cy="3086100"/>
+          </a:xfrm>
+          <a:prstGeom prst="rect">
+            <a:avLst/>
+          </a:prstGeom>
+          <a:noFill/>
+          <a:ln w="12700">
+            <a:solidFill>
+              <a:prstClr val="black"/>
+            </a:solidFill>
+          </a:ln>
+        </p:spPr>
+        <p:txBody>
+          <a:bodyPr vert="horz" lIns="91440" tIns="45720" rIns="91440" bIns="45720" rtlCol="0" anchor="ctr"/>
+          <a:lstStyle/>
+          <a:p>
+            <a:endParaRPr lang="en-US"/>
+          </a:p>
+        </p:txBody>
+      </p:sp>
+      <p:sp>
+        <p:nvSpPr>
+          <p:cNvPr id="5" name="Notes Placeholder 4"/>
+          <p:cNvSpPr>
+            <a:spLocks noGrp="1"/>
+          </p:cNvSpPr>
+          <p:nvPr>
+            <p:ph type="body" sz="quarter" idx="3"/>
+          </p:nvPr>
+        </p:nvSpPr>
+        <p:spPr>
+          <a:xfrm>
+            <a:off x="685800" y="4400550"/>
+            <a:ext cx="5486400" cy="3600450"/>
+          </a:xfrm>
+          <a:prstGeom prst="rect">
+            <a:avLst/>
+          </a:prstGeom>
+        </p:spPr>
+        <p:txBody>
+          <a:bodyPr vert="horz" lIns="91440" tIns="45720" rIns="91440" bIns="45720" rtlCol="0"/>
+          <a:lstStyle/>
+          <a:p>
+            <a:pPr lvl="0"/>
+            <a:r>
+              <a:rPr lang="en-US"/>
+              <a:t>Click to edit Master text styles</a:t>
+            </a:r>
+          </a:p>
+          <a:p>
+            <a:pPr lvl="1"/>
+            <a:r>
+              <a:rPr lang="en-US"/>
+              <a:t>Second level</a:t>
+            </a:r>
+          </a:p>
+          <a:p>
+            <a:pPr lvl="2"/>
+            <a:r>
+              <a:rPr lang="en-US"/>
+              <a:t>Third level</a:t>
+            </a:r>
+          </a:p>
+          <a:p>
+            <a:pPr lvl="3"/>
+            <a:r>
+              <a:rPr lang="en-US"/>
+              <a:t>Fourth level</a:t>
+            </a:r>
+          </a:p>
+          <a:p>
+            <a:pPr lvl="4"/>
+            <a:r>
+              <a:rPr lang="en-US"/>
+              <a:t>Fifth level</a:t>
+            </a:r>
+          </a:p>
+        </p:txBody>
+      </p:sp>
+      <p:sp>
+        <p:nvSpPr>
+          <p:cNvPr id="6" name="Footer Placeholder 5"/>
+          <p:cNvSpPr>
+            <a:spLocks noGrp="1"/>
+          </p:cNvSpPr>
+          <p:nvPr>
+            <p:ph type="ftr" sz="quarter" idx="4"/>
+          </p:nvPr>
+        </p:nvSpPr>
+        <p:spPr>
+          <a:xfrm>
+            <a:off x="0" y="8685213"/>
+            <a:ext cx="2971800" cy="458787"/>
+          </a:xfrm>
+          <a:prstGeom prst="rect">
+            <a:avLst/>
+          </a:prstGeom>
+        </p:spPr>
+        <p:txBody>
+          <a:bodyPr vert="horz" lIns="91440" tIns="45720" rIns="91440" bIns="45720" rtlCol="0" anchor="b"/>
+          <a:lstStyle>
+            <a:lvl1pPr algn="l">
+              <a:defRPr sz="1200"/>
+            </a:lvl1pPr>
+          </a:lstStyle>
+          <a:p>
+            <a:endParaRPr lang="en-US"/>
+          </a:p>
+        </p:txBody>
+      </p:sp>
+      <p:sp>
+        <p:nvSpPr>
+          <p:cNvPr id="7" name="Slide Number Placeholder 6"/>
+          <p:cNvSpPr>
+            <a:spLocks noGrp="1"/>
+          </p:cNvSpPr>
+          <p:nvPr>
+            <p:ph type="sldNum" sz="quarter" idx="5"/>
+          </p:nvPr>
+        </p:nvSpPr>
+        <p:spPr>
+          <a:xfrm>
+            <a:off x="3884613" y="8685213"/>
+            <a:ext cx="2971800" cy="458787"/>
+          </a:xfrm>
+          <a:prstGeom prst="rect">
+            <a:avLst/>
+          </a:prstGeom>
+        </p:spPr>
+        <p:txBody>
+          <a:bodyPr vert="horz" lIns="91440" tIns="45720" rIns="91440" bIns="45720" rtlCol="0" anchor="b"/>
+          <a:lstStyle>
+            <a:lvl1pPr algn="r">
+              <a:defRPr sz="1200"/>
+            </a:lvl1pPr>
+          </a:lstStyle>
+          <a:p>
+            <a:fld id="{AA0CCACE-AD26-4C7D-8D05-9EE2E6529D0E}" type="slidenum">
+              <a:rPr lang="en-US" smtClean="0"/>
+              <a:t>‹#›</a:t>
+            </a:fld>
+            <a:endParaRPr lang="en-US"/>
+          </a:p>
+        </p:txBody>
+      </p:sp>
+    </p:spTree>
+    <p:extLst>
+      <p:ext uri="{BB962C8B-B14F-4D97-AF65-F5344CB8AC3E}">
+        <p14:creationId xmlns:p14="http://schemas.microsoft.com/office/powerpoint/2010/main" val="586182700"/>
+      </p:ext>
+    </p:extLst>
+  </p:cSld>
+  <p:clrMap bg1="lt1" tx1="dk1" bg2="lt2" tx2="dk2" accent1="accent1" accent2="accent2" accent3="accent3" accent4="accent4" accent5="accent5" accent6="accent6" hlink="hlink" folHlink="folHlink"/>
+  <p:notesStyle>
+    <a:lvl1pPr marL="0" algn="l" defTabSz="914400" rtl="0" eaLnBrk="1" latinLnBrk="0" hangingPunct="1">
+      <a:defRPr sz="1200" kern="1200">
+        <a:solidFill>
+          <a:schemeClr val="tx1"/>
+        </a:solidFill>
+        <a:latin typeface="+mn-lt"/>
+        <a:ea typeface="+mn-ea"/>
+        <a:cs typeface="+mn-cs"/>
+      </a:defRPr>
+    </a:lvl1pPr>
+    <a:lvl2pPr marL="457200" algn="l" defTabSz="914400" rtl="0" eaLnBrk="1" latinLnBrk="0" hangingPunct="1">
+      <a:defRPr sz="1200" kern="1200">
+        <a:solidFill>
+          <a:schemeClr val="tx1"/>
+        </a:solidFill>
+        <a:latin typeface="+mn-lt"/>
+        <a:ea typeface="+mn-ea"/>
+        <a:cs typeface="+mn-cs"/>
+      </a:defRPr>
+    </a:lvl2pPr>
+    <a:lvl3pPr marL="914400" algn="l" defTabSz="914400" rtl="0" eaLnBrk="1" latinLnBrk="0" hangingPunct="1">
+      <a:defRPr sz="1200" kern="1200">
+        <a:solidFill>
+          <a:schemeClr val="tx1"/>
+        </a:solidFill>
+        <a:latin typeface="+mn-lt"/>
+        <a:ea typeface="+mn-ea"/>
+        <a:cs typeface="+mn-cs"/>
+      </a:defRPr>
+    </a:lvl3pPr>
+    <a:lvl4pPr marL="1371600" algn="l" defTabSz="914400" rtl="0" eaLnBrk="1" latinLnBrk="0" hangingPunct="1">
+      <a:defRPr sz="1200" kern="1200">
+        <a:solidFill>
+          <a:schemeClr val="tx1"/>
+        </a:solidFill>
+        <a:latin typeface="+mn-lt"/>
+        <a:ea typeface="+mn-ea"/>
+        <a:cs typeface="+mn-cs"/>
+      </a:defRPr>
+    </a:lvl4pPr>
+    <a:lvl5pPr marL="1828800" algn="l" defTabSz="914400" rtl="0" eaLnBrk="1" latinLnBrk="0" hangingPunct="1">
+      <a:defRPr sz="1200" kern="1200">
+        <a:solidFill>
+          <a:schemeClr val="tx1"/>
+        </a:solidFill>
+        <a:latin typeface="+mn-lt"/>
+        <a:ea typeface="+mn-ea"/>
+        <a:cs typeface="+mn-cs"/>
+      </a:defRPr>
+    </a:lvl5pPr>
+    <a:lvl6pPr marL="2286000" algn="l" defTabSz="914400" rtl="0" eaLnBrk="1" latinLnBrk="0" hangingPunct="1">
+      <a:defRPr sz="1200" kern="1200">
+        <a:solidFill>
+          <a:schemeClr val="tx1"/>
+        </a:solidFill>
+        <a:latin typeface="+mn-lt"/>
+        <a:ea typeface="+mn-ea"/>
+        <a:cs typeface="+mn-cs"/>
+      </a:defRPr>
+    </a:lvl6pPr>
+    <a:lvl7pPr marL="2743200" algn="l" defTabSz="914400" rtl="0" eaLnBrk="1" latinLnBrk="0" hangingPunct="1">
+      <a:defRPr sz="1200" kern="1200">
+        <a:solidFill>
+          <a:schemeClr val="tx1"/>
+        </a:solidFill>
+        <a:latin typeface="+mn-lt"/>
+        <a:ea typeface="+mn-ea"/>
+        <a:cs typeface="+mn-cs"/>
+      </a:defRPr>
+    </a:lvl7pPr>
+    <a:lvl8pPr marL="3200400" algn="l" defTabSz="914400" rtl="0" eaLnBrk="1" latinLnBrk="0" hangingPunct="1">
+      <a:defRPr sz="1200" kern="1200">
+        <a:solidFill>
+          <a:schemeClr val="tx1"/>
+        </a:solidFill>
+        <a:latin typeface="+mn-lt"/>
+        <a:ea typeface="+mn-ea"/>
+        <a:cs typeface="+mn-cs"/>
+      </a:defRPr>
+    </a:lvl8pPr>
+    <a:lvl9pPr marL="3657600" algn="l" defTabSz="914400" rtl="0" eaLnBrk="1" latinLnBrk="0" hangingPunct="1">
+      <a:defRPr sz="1200" kern="1200">
+        <a:solidFill>
+          <a:schemeClr val="tx1"/>
+        </a:solidFill>
+        <a:latin typeface="+mn-lt"/>
+        <a:ea typeface="+mn-ea"/>
+        <a:cs typeface="+mn-cs"/>
+      </a:defRPr>
+    </a:lvl9pPr>
+  </p:notesStyle>
+</p:notesMaster>
+</file>
+
+<file path=ppt/notesSlides/notesSlide1.xml><?xml version="1.0" encoding="utf-8"?>
+<p:notes xmlns:a="http://schemas.openxmlformats.org/drawingml/2006/main" xmlns:r="http://schemas.openxmlformats.org/officeDocument/2006/relationships" xmlns:p="http://schemas.openxmlformats.org/presentationml/2006/main">
+  <p:cSld>
+    <p:spTree>
+      <p:nvGrpSpPr>
+        <p:cNvPr id="1" name=""/>
+        <p:cNvGrpSpPr/>
+        <p:nvPr/>
+      </p:nvGrpSpPr>
+      <p:grpSpPr>
+        <a:xfrm>
+          <a:off x="0" y="0"/>
+          <a:ext cx="0" cy="0"/>
+          <a:chOff x="0" y="0"/>
+          <a:chExt cx="0" cy="0"/>
+        </a:xfrm>
+      </p:grpSpPr>
+      <p:sp>
+        <p:nvSpPr>
+          <p:cNvPr id="2" name="Slide Image Placeholder 1"/>
+          <p:cNvSpPr>
+            <a:spLocks noGrp="1" noRot="1" noChangeAspect="1"/>
+          </p:cNvSpPr>
+          <p:nvPr>
+            <p:ph type="sldImg"/>
+          </p:nvPr>
+        </p:nvSpPr>
+        <p:spPr/>
+      </p:sp>
+      <p:sp>
+        <p:nvSpPr>
+          <p:cNvPr id="3" name="Notes Placeholder 2"/>
+          <p:cNvSpPr>
+            <a:spLocks noGrp="1"/>
+          </p:cNvSpPr>
+          <p:nvPr>
+            <p:ph type="body" idx="1"/>
+          </p:nvPr>
+        </p:nvSpPr>
+        <p:spPr/>
+        <p:txBody>
+          <a:bodyPr/>
+          <a:lstStyle/>
+          <a:p>
+            <a:pPr marL="0" marR="0" lvl="0" indent="0" algn="l" defTabSz="914400" rtl="0" eaLnBrk="1" fontAlgn="auto" latinLnBrk="0" hangingPunct="1">
+              <a:lnSpc>
+                <a:spcPct val="100000"/>
+              </a:lnSpc>
+              <a:spcBef>
+                <a:spcPts val="0"/>
+              </a:spcBef>
+              <a:spcAft>
+                <a:spcPts val="0"/>
+              </a:spcAft>
+              <a:buClrTx/>
+              <a:buSzTx/>
+              <a:buFontTx/>
+              <a:buNone/>
+              <a:tabLst/>
+              <a:defRPr/>
+            </a:pPr>
+            <a:r>
+              <a:rPr lang="en-US" sz="1200" kern="1200" dirty="0">
+                <a:solidFill>
+                  <a:schemeClr val="tx1"/>
+                </a:solidFill>
+                <a:latin typeface="+mn-lt"/>
+                <a:ea typeface="+mn-ea"/>
+                <a:cs typeface="+mn-cs"/>
+              </a:rPr>
+              <a:t>The Problem</a:t>
+            </a:r>
+          </a:p>
+          <a:p>
+            <a:pPr marL="0" marR="0" lvl="0" indent="0" algn="l" defTabSz="914400" rtl="0" eaLnBrk="1" fontAlgn="auto" latinLnBrk="0" hangingPunct="1">
+              <a:lnSpc>
+                <a:spcPct val="100000"/>
+              </a:lnSpc>
+              <a:spcBef>
+                <a:spcPts val="0"/>
+              </a:spcBef>
+              <a:spcAft>
+                <a:spcPts val="0"/>
+              </a:spcAft>
+              <a:buClrTx/>
+              <a:buSzTx/>
+              <a:buFontTx/>
+              <a:buNone/>
+              <a:tabLst/>
+              <a:defRPr/>
+            </a:pPr>
+            <a:r>
+              <a:rPr lang="en-US" sz="1200" kern="1200" dirty="0">
+                <a:solidFill>
+                  <a:schemeClr val="tx1"/>
+                </a:solidFill>
+                <a:latin typeface="+mn-lt"/>
+                <a:ea typeface="+mn-ea"/>
+                <a:cs typeface="+mn-cs"/>
+              </a:rPr>
+              <a:t>When investing in a movie, how do you know if it will be successful or a flop?</a:t>
+            </a:r>
+          </a:p>
+          <a:p>
+            <a:endParaRPr lang="en-US" dirty="0"/>
+          </a:p>
+        </p:txBody>
+      </p:sp>
+      <p:sp>
+        <p:nvSpPr>
+          <p:cNvPr id="4" name="Slide Number Placeholder 3"/>
+          <p:cNvSpPr>
+            <a:spLocks noGrp="1"/>
+          </p:cNvSpPr>
+          <p:nvPr>
+            <p:ph type="sldNum" sz="quarter" idx="5"/>
+          </p:nvPr>
+        </p:nvSpPr>
+        <p:spPr/>
+        <p:txBody>
+          <a:bodyPr/>
+          <a:lstStyle/>
+          <a:p>
+            <a:fld id="{AA0CCACE-AD26-4C7D-8D05-9EE2E6529D0E}" type="slidenum">
+              <a:rPr lang="en-US" smtClean="0"/>
+              <a:t>2</a:t>
+            </a:fld>
+            <a:endParaRPr lang="en-US"/>
+          </a:p>
+        </p:txBody>
+      </p:sp>
+    </p:spTree>
+    <p:extLst>
+      <p:ext uri="{BB962C8B-B14F-4D97-AF65-F5344CB8AC3E}">
+        <p14:creationId xmlns:p14="http://schemas.microsoft.com/office/powerpoint/2010/main" val="3331152053"/>
+      </p:ext>
+    </p:extLst>
+  </p:cSld>
+  <p:clrMapOvr>
+    <a:masterClrMapping/>
+  </p:clrMapOvr>
+</p:notes>
+</file>
+
+<file path=ppt/notesSlides/notesSlide10.xml><?xml version="1.0" encoding="utf-8"?>
+<p:notes xmlns:a="http://schemas.openxmlformats.org/drawingml/2006/main" xmlns:r="http://schemas.openxmlformats.org/officeDocument/2006/relationships" xmlns:p="http://schemas.openxmlformats.org/presentationml/2006/main">
+  <p:cSld>
+    <p:spTree>
+      <p:nvGrpSpPr>
+        <p:cNvPr id="1" name=""/>
+        <p:cNvGrpSpPr/>
+        <p:nvPr/>
+      </p:nvGrpSpPr>
+      <p:grpSpPr>
+        <a:xfrm>
+          <a:off x="0" y="0"/>
+          <a:ext cx="0" cy="0"/>
+          <a:chOff x="0" y="0"/>
+          <a:chExt cx="0" cy="0"/>
+        </a:xfrm>
+      </p:grpSpPr>
+      <p:sp>
+        <p:nvSpPr>
+          <p:cNvPr id="2" name="Slide Image Placeholder 1"/>
+          <p:cNvSpPr>
+            <a:spLocks noGrp="1" noRot="1" noChangeAspect="1"/>
+          </p:cNvSpPr>
+          <p:nvPr>
+            <p:ph type="sldImg"/>
+          </p:nvPr>
+        </p:nvSpPr>
+        <p:spPr/>
+      </p:sp>
+      <p:sp>
+        <p:nvSpPr>
+          <p:cNvPr id="3" name="Notes Placeholder 2"/>
+          <p:cNvSpPr>
+            <a:spLocks noGrp="1"/>
+          </p:cNvSpPr>
+          <p:nvPr>
+            <p:ph type="body" idx="1"/>
+          </p:nvPr>
+        </p:nvSpPr>
+        <p:spPr/>
+        <p:txBody>
+          <a:bodyPr/>
+          <a:lstStyle/>
+          <a:p>
+            <a:r>
+              <a:rPr lang="en-US" dirty="0"/>
+              <a:t>This histogram shows the number of movies released by month. May, June, July, November and December have the most movie releases. So if you want to make a successful movie it would be best to release your film in those months. Hence the name summer blockbuster.</a:t>
+            </a:r>
+          </a:p>
+        </p:txBody>
+      </p:sp>
+      <p:sp>
+        <p:nvSpPr>
+          <p:cNvPr id="4" name="Slide Number Placeholder 3"/>
+          <p:cNvSpPr>
+            <a:spLocks noGrp="1"/>
+          </p:cNvSpPr>
+          <p:nvPr>
+            <p:ph type="sldNum" sz="quarter" idx="5"/>
+          </p:nvPr>
+        </p:nvSpPr>
+        <p:spPr/>
+        <p:txBody>
+          <a:bodyPr/>
+          <a:lstStyle/>
+          <a:p>
+            <a:fld id="{AA0CCACE-AD26-4C7D-8D05-9EE2E6529D0E}" type="slidenum">
+              <a:rPr lang="en-US" smtClean="0"/>
+              <a:t>12</a:t>
+            </a:fld>
+            <a:endParaRPr lang="en-US"/>
+          </a:p>
+        </p:txBody>
+      </p:sp>
+    </p:spTree>
+    <p:extLst>
+      <p:ext uri="{BB962C8B-B14F-4D97-AF65-F5344CB8AC3E}">
+        <p14:creationId xmlns:p14="http://schemas.microsoft.com/office/powerpoint/2010/main" val="3923111643"/>
+      </p:ext>
+    </p:extLst>
+  </p:cSld>
+  <p:clrMapOvr>
+    <a:masterClrMapping/>
+  </p:clrMapOvr>
+</p:notes>
+</file>
+
+<file path=ppt/notesSlides/notesSlide11.xml><?xml version="1.0" encoding="utf-8"?>
+<p:notes xmlns:a="http://schemas.openxmlformats.org/drawingml/2006/main" xmlns:r="http://schemas.openxmlformats.org/officeDocument/2006/relationships" xmlns:p="http://schemas.openxmlformats.org/presentationml/2006/main">
+  <p:cSld>
+    <p:spTree>
+      <p:nvGrpSpPr>
+        <p:cNvPr id="1" name=""/>
+        <p:cNvGrpSpPr/>
+        <p:nvPr/>
+      </p:nvGrpSpPr>
+      <p:grpSpPr>
+        <a:xfrm>
+          <a:off x="0" y="0"/>
+          <a:ext cx="0" cy="0"/>
+          <a:chOff x="0" y="0"/>
+          <a:chExt cx="0" cy="0"/>
+        </a:xfrm>
+      </p:grpSpPr>
+      <p:sp>
+        <p:nvSpPr>
+          <p:cNvPr id="2" name="Slide Image Placeholder 1"/>
+          <p:cNvSpPr>
+            <a:spLocks noGrp="1" noRot="1" noChangeAspect="1"/>
+          </p:cNvSpPr>
+          <p:nvPr>
+            <p:ph type="sldImg"/>
+          </p:nvPr>
+        </p:nvSpPr>
+        <p:spPr/>
+      </p:sp>
+      <p:sp>
+        <p:nvSpPr>
+          <p:cNvPr id="3" name="Notes Placeholder 2"/>
+          <p:cNvSpPr>
+            <a:spLocks noGrp="1"/>
+          </p:cNvSpPr>
+          <p:nvPr>
+            <p:ph type="body" idx="1"/>
+          </p:nvPr>
+        </p:nvSpPr>
+        <p:spPr/>
+        <p:txBody>
+          <a:bodyPr/>
+          <a:lstStyle/>
+          <a:p>
+            <a:r>
+              <a:rPr lang="en-US" dirty="0"/>
+              <a:t>These graphs show movies’ ROIs and Net Profit grouped by month, respectively. They show movies released in May, June, July, November and December preform best.</a:t>
+            </a:r>
+          </a:p>
+        </p:txBody>
+      </p:sp>
+      <p:sp>
+        <p:nvSpPr>
+          <p:cNvPr id="4" name="Slide Number Placeholder 3"/>
+          <p:cNvSpPr>
+            <a:spLocks noGrp="1"/>
+          </p:cNvSpPr>
+          <p:nvPr>
+            <p:ph type="sldNum" sz="quarter" idx="5"/>
+          </p:nvPr>
+        </p:nvSpPr>
+        <p:spPr/>
+        <p:txBody>
+          <a:bodyPr/>
+          <a:lstStyle/>
+          <a:p>
+            <a:fld id="{AA0CCACE-AD26-4C7D-8D05-9EE2E6529D0E}" type="slidenum">
+              <a:rPr lang="en-US" smtClean="0"/>
+              <a:t>13</a:t>
+            </a:fld>
+            <a:endParaRPr lang="en-US"/>
+          </a:p>
+        </p:txBody>
+      </p:sp>
+    </p:spTree>
+    <p:extLst>
+      <p:ext uri="{BB962C8B-B14F-4D97-AF65-F5344CB8AC3E}">
+        <p14:creationId xmlns:p14="http://schemas.microsoft.com/office/powerpoint/2010/main" val="3728078711"/>
+      </p:ext>
+    </p:extLst>
+  </p:cSld>
+  <p:clrMapOvr>
+    <a:masterClrMapping/>
+  </p:clrMapOvr>
+</p:notes>
+</file>
+
+<file path=ppt/notesSlides/notesSlide12.xml><?xml version="1.0" encoding="utf-8"?>
+<p:notes xmlns:a="http://schemas.openxmlformats.org/drawingml/2006/main" xmlns:r="http://schemas.openxmlformats.org/officeDocument/2006/relationships" xmlns:p="http://schemas.openxmlformats.org/presentationml/2006/main">
+  <p:cSld>
+    <p:spTree>
+      <p:nvGrpSpPr>
+        <p:cNvPr id="1" name=""/>
+        <p:cNvGrpSpPr/>
+        <p:nvPr/>
+      </p:nvGrpSpPr>
+      <p:grpSpPr>
+        <a:xfrm>
+          <a:off x="0" y="0"/>
+          <a:ext cx="0" cy="0"/>
+          <a:chOff x="0" y="0"/>
+          <a:chExt cx="0" cy="0"/>
+        </a:xfrm>
+      </p:grpSpPr>
+      <p:sp>
+        <p:nvSpPr>
+          <p:cNvPr id="2" name="Slide Image Placeholder 1"/>
+          <p:cNvSpPr>
+            <a:spLocks noGrp="1" noRot="1" noChangeAspect="1"/>
+          </p:cNvSpPr>
+          <p:nvPr>
+            <p:ph type="sldImg"/>
+          </p:nvPr>
+        </p:nvSpPr>
+        <p:spPr/>
+      </p:sp>
+      <p:sp>
+        <p:nvSpPr>
+          <p:cNvPr id="3" name="Notes Placeholder 2"/>
+          <p:cNvSpPr>
+            <a:spLocks noGrp="1"/>
+          </p:cNvSpPr>
+          <p:nvPr>
+            <p:ph type="body" idx="1"/>
+          </p:nvPr>
+        </p:nvSpPr>
+        <p:spPr/>
+        <p:txBody>
+          <a:bodyPr/>
+          <a:lstStyle/>
+          <a:p>
+            <a:r>
+              <a:rPr lang="en-US" dirty="0"/>
+              <a:t>This graph shows movies review ratings grouped by month. Again, movies released in May, June, July, November and December have the best reviews.</a:t>
+            </a:r>
+          </a:p>
+        </p:txBody>
+      </p:sp>
+      <p:sp>
+        <p:nvSpPr>
+          <p:cNvPr id="4" name="Slide Number Placeholder 3"/>
+          <p:cNvSpPr>
+            <a:spLocks noGrp="1"/>
+          </p:cNvSpPr>
+          <p:nvPr>
+            <p:ph type="sldNum" sz="quarter" idx="5"/>
+          </p:nvPr>
+        </p:nvSpPr>
+        <p:spPr/>
+        <p:txBody>
+          <a:bodyPr/>
+          <a:lstStyle/>
+          <a:p>
+            <a:fld id="{AA0CCACE-AD26-4C7D-8D05-9EE2E6529D0E}" type="slidenum">
+              <a:rPr lang="en-US" smtClean="0"/>
+              <a:t>14</a:t>
+            </a:fld>
+            <a:endParaRPr lang="en-US"/>
+          </a:p>
+        </p:txBody>
+      </p:sp>
+    </p:spTree>
+    <p:extLst>
+      <p:ext uri="{BB962C8B-B14F-4D97-AF65-F5344CB8AC3E}">
+        <p14:creationId xmlns:p14="http://schemas.microsoft.com/office/powerpoint/2010/main" val="1851444215"/>
+      </p:ext>
+    </p:extLst>
+  </p:cSld>
+  <p:clrMapOvr>
+    <a:masterClrMapping/>
+  </p:clrMapOvr>
+</p:notes>
+</file>
+
+<file path=ppt/notesSlides/notesSlide13.xml><?xml version="1.0" encoding="utf-8"?>
+<p:notes xmlns:a="http://schemas.openxmlformats.org/drawingml/2006/main" xmlns:r="http://schemas.openxmlformats.org/officeDocument/2006/relationships" xmlns:p="http://schemas.openxmlformats.org/presentationml/2006/main">
+  <p:cSld>
+    <p:spTree>
+      <p:nvGrpSpPr>
+        <p:cNvPr id="1" name=""/>
+        <p:cNvGrpSpPr/>
+        <p:nvPr/>
+      </p:nvGrpSpPr>
+      <p:grpSpPr>
+        <a:xfrm>
+          <a:off x="0" y="0"/>
+          <a:ext cx="0" cy="0"/>
+          <a:chOff x="0" y="0"/>
+          <a:chExt cx="0" cy="0"/>
+        </a:xfrm>
+      </p:grpSpPr>
+      <p:sp>
+        <p:nvSpPr>
+          <p:cNvPr id="2" name="Slide Image Placeholder 1"/>
+          <p:cNvSpPr>
+            <a:spLocks noGrp="1" noRot="1" noChangeAspect="1"/>
+          </p:cNvSpPr>
+          <p:nvPr>
+            <p:ph type="sldImg"/>
+          </p:nvPr>
+        </p:nvSpPr>
+        <p:spPr/>
+      </p:sp>
+      <p:sp>
+        <p:nvSpPr>
+          <p:cNvPr id="3" name="Notes Placeholder 2"/>
+          <p:cNvSpPr>
+            <a:spLocks noGrp="1"/>
+          </p:cNvSpPr>
+          <p:nvPr>
+            <p:ph type="body" idx="1"/>
+          </p:nvPr>
+        </p:nvSpPr>
+        <p:spPr/>
+        <p:txBody>
+          <a:bodyPr/>
+          <a:lstStyle/>
+          <a:p>
+            <a:r>
+              <a:rPr lang="en-US" dirty="0"/>
+              <a:t>This graph shows the number of movies released by month grouped by MPAA rating. The most common rating is PG-13.</a:t>
+            </a:r>
+          </a:p>
+        </p:txBody>
+      </p:sp>
+      <p:sp>
+        <p:nvSpPr>
+          <p:cNvPr id="4" name="Slide Number Placeholder 3"/>
+          <p:cNvSpPr>
+            <a:spLocks noGrp="1"/>
+          </p:cNvSpPr>
+          <p:nvPr>
+            <p:ph type="sldNum" sz="quarter" idx="5"/>
+          </p:nvPr>
+        </p:nvSpPr>
+        <p:spPr/>
+        <p:txBody>
+          <a:bodyPr/>
+          <a:lstStyle/>
+          <a:p>
+            <a:fld id="{AA0CCACE-AD26-4C7D-8D05-9EE2E6529D0E}" type="slidenum">
+              <a:rPr lang="en-US" smtClean="0"/>
+              <a:t>15</a:t>
+            </a:fld>
+            <a:endParaRPr lang="en-US"/>
+          </a:p>
+        </p:txBody>
+      </p:sp>
+    </p:spTree>
+    <p:extLst>
+      <p:ext uri="{BB962C8B-B14F-4D97-AF65-F5344CB8AC3E}">
+        <p14:creationId xmlns:p14="http://schemas.microsoft.com/office/powerpoint/2010/main" val="2836708230"/>
+      </p:ext>
+    </p:extLst>
+  </p:cSld>
+  <p:clrMapOvr>
+    <a:masterClrMapping/>
+  </p:clrMapOvr>
+</p:notes>
+</file>
+
+<file path=ppt/notesSlides/notesSlide14.xml><?xml version="1.0" encoding="utf-8"?>
+<p:notes xmlns:a="http://schemas.openxmlformats.org/drawingml/2006/main" xmlns:r="http://schemas.openxmlformats.org/officeDocument/2006/relationships" xmlns:p="http://schemas.openxmlformats.org/presentationml/2006/main">
+  <p:cSld>
+    <p:spTree>
+      <p:nvGrpSpPr>
+        <p:cNvPr id="1" name=""/>
+        <p:cNvGrpSpPr/>
+        <p:nvPr/>
+      </p:nvGrpSpPr>
+      <p:grpSpPr>
+        <a:xfrm>
+          <a:off x="0" y="0"/>
+          <a:ext cx="0" cy="0"/>
+          <a:chOff x="0" y="0"/>
+          <a:chExt cx="0" cy="0"/>
+        </a:xfrm>
+      </p:grpSpPr>
+      <p:sp>
+        <p:nvSpPr>
+          <p:cNvPr id="2" name="Slide Image Placeholder 1"/>
+          <p:cNvSpPr>
+            <a:spLocks noGrp="1" noRot="1" noChangeAspect="1"/>
+          </p:cNvSpPr>
+          <p:nvPr>
+            <p:ph type="sldImg"/>
+          </p:nvPr>
+        </p:nvSpPr>
+        <p:spPr/>
+      </p:sp>
+      <p:sp>
+        <p:nvSpPr>
+          <p:cNvPr id="3" name="Notes Placeholder 2"/>
+          <p:cNvSpPr>
+            <a:spLocks noGrp="1"/>
+          </p:cNvSpPr>
+          <p:nvPr>
+            <p:ph type="body" idx="1"/>
+          </p:nvPr>
+        </p:nvSpPr>
+        <p:spPr/>
+        <p:txBody>
+          <a:bodyPr/>
+          <a:lstStyle/>
+          <a:p>
+            <a:r>
+              <a:rPr lang="en-US" dirty="0"/>
+              <a:t>This is a heat map of all the correlations in this data set. The circled values are the most correlated features. There are three predictive variables, gross, net profit, and ROI. </a:t>
+            </a:r>
+          </a:p>
+          <a:p>
+            <a:endParaRPr lang="en-US" dirty="0"/>
+          </a:p>
+          <a:p>
+            <a:r>
+              <a:rPr lang="en-US" dirty="0"/>
+              <a:t>Gross and net profit were calculated off each other, so they have a very high correlation rate. </a:t>
+            </a:r>
+          </a:p>
+          <a:p>
+            <a:endParaRPr lang="en-US" dirty="0"/>
+          </a:p>
+          <a:p>
+            <a:r>
+              <a:rPr lang="en-US" dirty="0"/>
+              <a:t>The movies’ ROI averages are similar for most the movies in this data set. That is why there are not high correlations when looking at it’s row.</a:t>
+            </a:r>
+          </a:p>
+        </p:txBody>
+      </p:sp>
+      <p:sp>
+        <p:nvSpPr>
+          <p:cNvPr id="4" name="Slide Number Placeholder 3"/>
+          <p:cNvSpPr>
+            <a:spLocks noGrp="1"/>
+          </p:cNvSpPr>
+          <p:nvPr>
+            <p:ph type="sldNum" sz="quarter" idx="5"/>
+          </p:nvPr>
+        </p:nvSpPr>
+        <p:spPr/>
+        <p:txBody>
+          <a:bodyPr/>
+          <a:lstStyle/>
+          <a:p>
+            <a:fld id="{AA0CCACE-AD26-4C7D-8D05-9EE2E6529D0E}" type="slidenum">
+              <a:rPr lang="en-US" smtClean="0"/>
+              <a:t>16</a:t>
+            </a:fld>
+            <a:endParaRPr lang="en-US"/>
+          </a:p>
+        </p:txBody>
+      </p:sp>
+    </p:spTree>
+    <p:extLst>
+      <p:ext uri="{BB962C8B-B14F-4D97-AF65-F5344CB8AC3E}">
+        <p14:creationId xmlns:p14="http://schemas.microsoft.com/office/powerpoint/2010/main" val="307535049"/>
+      </p:ext>
+    </p:extLst>
+  </p:cSld>
+  <p:clrMapOvr>
+    <a:masterClrMapping/>
+  </p:clrMapOvr>
+</p:notes>
+</file>
+
+<file path=ppt/notesSlides/notesSlide15.xml><?xml version="1.0" encoding="utf-8"?>
+<p:notes xmlns:a="http://schemas.openxmlformats.org/drawingml/2006/main" xmlns:r="http://schemas.openxmlformats.org/officeDocument/2006/relationships" xmlns:p="http://schemas.openxmlformats.org/presentationml/2006/main">
+  <p:cSld>
+    <p:spTree>
+      <p:nvGrpSpPr>
+        <p:cNvPr id="1" name=""/>
+        <p:cNvGrpSpPr/>
+        <p:nvPr/>
+      </p:nvGrpSpPr>
+      <p:grpSpPr>
+        <a:xfrm>
+          <a:off x="0" y="0"/>
+          <a:ext cx="0" cy="0"/>
+          <a:chOff x="0" y="0"/>
+          <a:chExt cx="0" cy="0"/>
+        </a:xfrm>
+      </p:grpSpPr>
+      <p:sp>
+        <p:nvSpPr>
+          <p:cNvPr id="2" name="Slide Image Placeholder 1"/>
+          <p:cNvSpPr>
+            <a:spLocks noGrp="1" noRot="1" noChangeAspect="1"/>
+          </p:cNvSpPr>
+          <p:nvPr>
+            <p:ph type="sldImg"/>
+          </p:nvPr>
+        </p:nvSpPr>
+        <p:spPr/>
+      </p:sp>
+      <p:sp>
+        <p:nvSpPr>
+          <p:cNvPr id="3" name="Notes Placeholder 2"/>
+          <p:cNvSpPr>
+            <a:spLocks noGrp="1"/>
+          </p:cNvSpPr>
+          <p:nvPr>
+            <p:ph type="body" idx="1"/>
+          </p:nvPr>
+        </p:nvSpPr>
+        <p:spPr/>
+        <p:txBody>
+          <a:bodyPr/>
+          <a:lstStyle/>
+          <a:p>
+            <a:r>
+              <a:rPr lang="en-US" dirty="0"/>
+              <a:t>Gross was chosen to be used as the predictive variable for modeling. ROI and Net profit were not included as features due to data leakage issues.</a:t>
+            </a:r>
+          </a:p>
+          <a:p>
+            <a:endParaRPr lang="en-US" dirty="0"/>
+          </a:p>
+          <a:p>
+            <a:r>
+              <a:rPr lang="en-US" dirty="0"/>
+              <a:t>Month was encoded as sine/cosine features.</a:t>
+            </a:r>
+          </a:p>
+          <a:p>
+            <a:endParaRPr lang="en-US" dirty="0"/>
+          </a:p>
+          <a:p>
+            <a:r>
+              <a:rPr lang="en-US" dirty="0"/>
+              <a:t>4 models were tested.</a:t>
+            </a:r>
+          </a:p>
+        </p:txBody>
+      </p:sp>
+      <p:sp>
+        <p:nvSpPr>
+          <p:cNvPr id="4" name="Slide Number Placeholder 3"/>
+          <p:cNvSpPr>
+            <a:spLocks noGrp="1"/>
+          </p:cNvSpPr>
+          <p:nvPr>
+            <p:ph type="sldNum" sz="quarter" idx="5"/>
+          </p:nvPr>
+        </p:nvSpPr>
+        <p:spPr/>
+        <p:txBody>
+          <a:bodyPr/>
+          <a:lstStyle/>
+          <a:p>
+            <a:fld id="{AA0CCACE-AD26-4C7D-8D05-9EE2E6529D0E}" type="slidenum">
+              <a:rPr lang="en-US" smtClean="0"/>
+              <a:t>17</a:t>
+            </a:fld>
+            <a:endParaRPr lang="en-US"/>
+          </a:p>
+        </p:txBody>
+      </p:sp>
+    </p:spTree>
+    <p:extLst>
+      <p:ext uri="{BB962C8B-B14F-4D97-AF65-F5344CB8AC3E}">
+        <p14:creationId xmlns:p14="http://schemas.microsoft.com/office/powerpoint/2010/main" val="2218033393"/>
+      </p:ext>
+    </p:extLst>
+  </p:cSld>
+  <p:clrMapOvr>
+    <a:masterClrMapping/>
+  </p:clrMapOvr>
+</p:notes>
+</file>
+
+<file path=ppt/notesSlides/notesSlide16.xml><?xml version="1.0" encoding="utf-8"?>
+<p:notes xmlns:a="http://schemas.openxmlformats.org/drawingml/2006/main" xmlns:r="http://schemas.openxmlformats.org/officeDocument/2006/relationships" xmlns:p="http://schemas.openxmlformats.org/presentationml/2006/main">
+  <p:cSld>
+    <p:spTree>
+      <p:nvGrpSpPr>
+        <p:cNvPr id="1" name=""/>
+        <p:cNvGrpSpPr/>
+        <p:nvPr/>
+      </p:nvGrpSpPr>
+      <p:grpSpPr>
+        <a:xfrm>
+          <a:off x="0" y="0"/>
+          <a:ext cx="0" cy="0"/>
+          <a:chOff x="0" y="0"/>
+          <a:chExt cx="0" cy="0"/>
+        </a:xfrm>
+      </p:grpSpPr>
+      <p:sp>
+        <p:nvSpPr>
+          <p:cNvPr id="2" name="Slide Image Placeholder 1"/>
+          <p:cNvSpPr>
+            <a:spLocks noGrp="1" noRot="1" noChangeAspect="1"/>
+          </p:cNvSpPr>
+          <p:nvPr>
+            <p:ph type="sldImg"/>
+          </p:nvPr>
+        </p:nvSpPr>
+        <p:spPr/>
+      </p:sp>
+      <p:sp>
+        <p:nvSpPr>
+          <p:cNvPr id="3" name="Notes Placeholder 2"/>
+          <p:cNvSpPr>
+            <a:spLocks noGrp="1"/>
+          </p:cNvSpPr>
+          <p:nvPr>
+            <p:ph type="body" idx="1"/>
+          </p:nvPr>
+        </p:nvSpPr>
+        <p:spPr/>
+        <p:txBody>
+          <a:bodyPr/>
+          <a:lstStyle/>
+          <a:p>
+            <a:r>
+              <a:rPr lang="en-US" dirty="0"/>
+              <a:t>Model Metrics</a:t>
+            </a:r>
+          </a:p>
+          <a:p>
+            <a:r>
+              <a:rPr lang="en-US" dirty="0"/>
+              <a:t>SVR was chosen for the final model because it had the highest R^2 testing value, and the lowest mean absolute error (MAE). It also had less difference between training and testing R^2 values. Random forest and </a:t>
+            </a:r>
+            <a:r>
+              <a:rPr lang="en-US" dirty="0" err="1"/>
+              <a:t>XGBoost</a:t>
+            </a:r>
+            <a:r>
+              <a:rPr lang="en-US" dirty="0"/>
+              <a:t> models overfit the training data indicated by the difference between training and testing R^2 values.</a:t>
+            </a:r>
+          </a:p>
+          <a:p>
+            <a:endParaRPr lang="en-US" dirty="0"/>
+          </a:p>
+          <a:p>
+            <a:r>
+              <a:rPr lang="en-US" dirty="0"/>
+              <a:t>The SVR grid search returned a testing R^2 0.03 higher than the default SVR model. However, also has a much higher MAE when compared to the default SVR model. The MAE represents tens of millions of dollars, so 0.31 to 0.42 is a very big difference. </a:t>
+            </a:r>
+          </a:p>
+          <a:p>
+            <a:endParaRPr lang="en-US" dirty="0"/>
+          </a:p>
+          <a:p>
+            <a:r>
+              <a:rPr lang="en-US" dirty="0"/>
+              <a:t>It is important to note that Random forest K fold R^2 testing outperformed SVR’s K fold R^2. </a:t>
+            </a:r>
+          </a:p>
+          <a:p>
+            <a:endParaRPr lang="en-US" dirty="0"/>
+          </a:p>
+          <a:p>
+            <a:r>
+              <a:rPr lang="en-US" dirty="0"/>
+              <a:t>Linear regression shows the least over fitting, preforms similar to the other models and takes much less time to compute. It would be a valid choice if we wanted the fastest computing time.</a:t>
+            </a:r>
+          </a:p>
+        </p:txBody>
+      </p:sp>
+      <p:sp>
+        <p:nvSpPr>
+          <p:cNvPr id="4" name="Slide Number Placeholder 3"/>
+          <p:cNvSpPr>
+            <a:spLocks noGrp="1"/>
+          </p:cNvSpPr>
+          <p:nvPr>
+            <p:ph type="sldNum" sz="quarter" idx="5"/>
+          </p:nvPr>
+        </p:nvSpPr>
+        <p:spPr/>
+        <p:txBody>
+          <a:bodyPr/>
+          <a:lstStyle/>
+          <a:p>
+            <a:fld id="{AA0CCACE-AD26-4C7D-8D05-9EE2E6529D0E}" type="slidenum">
+              <a:rPr lang="en-US" smtClean="0"/>
+              <a:t>18</a:t>
+            </a:fld>
+            <a:endParaRPr lang="en-US"/>
+          </a:p>
+        </p:txBody>
+      </p:sp>
+    </p:spTree>
+    <p:extLst>
+      <p:ext uri="{BB962C8B-B14F-4D97-AF65-F5344CB8AC3E}">
+        <p14:creationId xmlns:p14="http://schemas.microsoft.com/office/powerpoint/2010/main" val="100669273"/>
+      </p:ext>
+    </p:extLst>
+  </p:cSld>
+  <p:clrMapOvr>
+    <a:masterClrMapping/>
+  </p:clrMapOvr>
+</p:notes>
+</file>
+
+<file path=ppt/notesSlides/notesSlide17.xml><?xml version="1.0" encoding="utf-8"?>
+<p:notes xmlns:a="http://schemas.openxmlformats.org/drawingml/2006/main" xmlns:r="http://schemas.openxmlformats.org/officeDocument/2006/relationships" xmlns:p="http://schemas.openxmlformats.org/presentationml/2006/main">
+  <p:cSld>
+    <p:spTree>
+      <p:nvGrpSpPr>
+        <p:cNvPr id="1" name=""/>
+        <p:cNvGrpSpPr/>
+        <p:nvPr/>
+      </p:nvGrpSpPr>
+      <p:grpSpPr>
+        <a:xfrm>
+          <a:off x="0" y="0"/>
+          <a:ext cx="0" cy="0"/>
+          <a:chOff x="0" y="0"/>
+          <a:chExt cx="0" cy="0"/>
+        </a:xfrm>
+      </p:grpSpPr>
+      <p:sp>
+        <p:nvSpPr>
+          <p:cNvPr id="2" name="Slide Image Placeholder 1"/>
+          <p:cNvSpPr>
+            <a:spLocks noGrp="1" noRot="1" noChangeAspect="1"/>
+          </p:cNvSpPr>
+          <p:nvPr>
+            <p:ph type="sldImg"/>
+          </p:nvPr>
+        </p:nvSpPr>
+        <p:spPr/>
+      </p:sp>
+      <p:sp>
+        <p:nvSpPr>
+          <p:cNvPr id="3" name="Notes Placeholder 2"/>
+          <p:cNvSpPr>
+            <a:spLocks noGrp="1"/>
+          </p:cNvSpPr>
+          <p:nvPr>
+            <p:ph type="body" idx="1"/>
+          </p:nvPr>
+        </p:nvSpPr>
+        <p:spPr/>
+        <p:txBody>
+          <a:bodyPr/>
+          <a:lstStyle/>
+          <a:p>
+            <a:r>
+              <a:rPr lang="en-US" dirty="0"/>
+              <a:t>These graphs show Linear Regression and SVR models actual vs predictive values. We know that SVR preformed better than linear regression based on metrics, however visually they are very similar. You can also see that the movies in the data set have a narrow range of gross values. </a:t>
+            </a:r>
+          </a:p>
+        </p:txBody>
+      </p:sp>
+      <p:sp>
+        <p:nvSpPr>
+          <p:cNvPr id="4" name="Slide Number Placeholder 3"/>
+          <p:cNvSpPr>
+            <a:spLocks noGrp="1"/>
+          </p:cNvSpPr>
+          <p:nvPr>
+            <p:ph type="sldNum" sz="quarter" idx="5"/>
+          </p:nvPr>
+        </p:nvSpPr>
+        <p:spPr/>
+        <p:txBody>
+          <a:bodyPr/>
+          <a:lstStyle/>
+          <a:p>
+            <a:fld id="{AA0CCACE-AD26-4C7D-8D05-9EE2E6529D0E}" type="slidenum">
+              <a:rPr lang="en-US" smtClean="0"/>
+              <a:t>19</a:t>
+            </a:fld>
+            <a:endParaRPr lang="en-US"/>
+          </a:p>
+        </p:txBody>
+      </p:sp>
+    </p:spTree>
+    <p:extLst>
+      <p:ext uri="{BB962C8B-B14F-4D97-AF65-F5344CB8AC3E}">
+        <p14:creationId xmlns:p14="http://schemas.microsoft.com/office/powerpoint/2010/main" val="3334203083"/>
+      </p:ext>
+    </p:extLst>
+  </p:cSld>
+  <p:clrMapOvr>
+    <a:masterClrMapping/>
+  </p:clrMapOvr>
+</p:notes>
+</file>
+
+<file path=ppt/notesSlides/notesSlide18.xml><?xml version="1.0" encoding="utf-8"?>
+<p:notes xmlns:a="http://schemas.openxmlformats.org/drawingml/2006/main" xmlns:r="http://schemas.openxmlformats.org/officeDocument/2006/relationships" xmlns:p="http://schemas.openxmlformats.org/presentationml/2006/main">
+  <p:cSld>
+    <p:spTree>
+      <p:nvGrpSpPr>
+        <p:cNvPr id="1" name=""/>
+        <p:cNvGrpSpPr/>
+        <p:nvPr/>
+      </p:nvGrpSpPr>
+      <p:grpSpPr>
+        <a:xfrm>
+          <a:off x="0" y="0"/>
+          <a:ext cx="0" cy="0"/>
+          <a:chOff x="0" y="0"/>
+          <a:chExt cx="0" cy="0"/>
+        </a:xfrm>
+      </p:grpSpPr>
+      <p:sp>
+        <p:nvSpPr>
+          <p:cNvPr id="2" name="Slide Image Placeholder 1"/>
+          <p:cNvSpPr>
+            <a:spLocks noGrp="1" noRot="1" noChangeAspect="1"/>
+          </p:cNvSpPr>
+          <p:nvPr>
+            <p:ph type="sldImg"/>
+          </p:nvPr>
+        </p:nvSpPr>
+        <p:spPr/>
+      </p:sp>
+      <p:sp>
+        <p:nvSpPr>
+          <p:cNvPr id="3" name="Notes Placeholder 2"/>
+          <p:cNvSpPr>
+            <a:spLocks noGrp="1"/>
+          </p:cNvSpPr>
+          <p:nvPr>
+            <p:ph type="body" idx="1"/>
+          </p:nvPr>
+        </p:nvSpPr>
+        <p:spPr/>
+        <p:txBody>
+          <a:bodyPr/>
+          <a:lstStyle/>
+          <a:p>
+            <a:r>
+              <a:rPr lang="en-US" dirty="0"/>
+              <a:t>This data only includes successful blockbuster movies. It can predict a movies success, but it cannot predict if a movie will flop. The final SVR model also isn’t helpful for lower budget movies because the MAE has a multimillion-dollar range. The model will only work for movies that have a budget of hundreds of millions of dollars, and most likely will already be successful.</a:t>
+            </a:r>
+          </a:p>
+        </p:txBody>
+      </p:sp>
+      <p:sp>
+        <p:nvSpPr>
+          <p:cNvPr id="4" name="Slide Number Placeholder 3"/>
+          <p:cNvSpPr>
+            <a:spLocks noGrp="1"/>
+          </p:cNvSpPr>
+          <p:nvPr>
+            <p:ph type="sldNum" sz="quarter" idx="5"/>
+          </p:nvPr>
+        </p:nvSpPr>
+        <p:spPr/>
+        <p:txBody>
+          <a:bodyPr/>
+          <a:lstStyle/>
+          <a:p>
+            <a:fld id="{AA0CCACE-AD26-4C7D-8D05-9EE2E6529D0E}" type="slidenum">
+              <a:rPr lang="en-US" smtClean="0"/>
+              <a:t>20</a:t>
+            </a:fld>
+            <a:endParaRPr lang="en-US"/>
+          </a:p>
+        </p:txBody>
+      </p:sp>
+    </p:spTree>
+    <p:extLst>
+      <p:ext uri="{BB962C8B-B14F-4D97-AF65-F5344CB8AC3E}">
+        <p14:creationId xmlns:p14="http://schemas.microsoft.com/office/powerpoint/2010/main" val="1125477868"/>
+      </p:ext>
+    </p:extLst>
+  </p:cSld>
+  <p:clrMapOvr>
+    <a:masterClrMapping/>
+  </p:clrMapOvr>
+</p:notes>
+</file>
+
+<file path=ppt/notesSlides/notesSlide19.xml><?xml version="1.0" encoding="utf-8"?>
+<p:notes xmlns:a="http://schemas.openxmlformats.org/drawingml/2006/main" xmlns:r="http://schemas.openxmlformats.org/officeDocument/2006/relationships" xmlns:p="http://schemas.openxmlformats.org/presentationml/2006/main">
+  <p:cSld>
+    <p:spTree>
+      <p:nvGrpSpPr>
+        <p:cNvPr id="1" name=""/>
+        <p:cNvGrpSpPr/>
+        <p:nvPr/>
+      </p:nvGrpSpPr>
+      <p:grpSpPr>
+        <a:xfrm>
+          <a:off x="0" y="0"/>
+          <a:ext cx="0" cy="0"/>
+          <a:chOff x="0" y="0"/>
+          <a:chExt cx="0" cy="0"/>
+        </a:xfrm>
+      </p:grpSpPr>
+      <p:sp>
+        <p:nvSpPr>
+          <p:cNvPr id="2" name="Slide Image Placeholder 1"/>
+          <p:cNvSpPr>
+            <a:spLocks noGrp="1" noRot="1" noChangeAspect="1"/>
+          </p:cNvSpPr>
+          <p:nvPr>
+            <p:ph type="sldImg"/>
+          </p:nvPr>
+        </p:nvSpPr>
+        <p:spPr/>
+      </p:sp>
+      <p:sp>
+        <p:nvSpPr>
+          <p:cNvPr id="3" name="Notes Placeholder 2"/>
+          <p:cNvSpPr>
+            <a:spLocks noGrp="1"/>
+          </p:cNvSpPr>
+          <p:nvPr>
+            <p:ph type="body" idx="1"/>
+          </p:nvPr>
+        </p:nvSpPr>
+        <p:spPr/>
+        <p:txBody>
+          <a:bodyPr/>
+          <a:lstStyle/>
+          <a:p>
+            <a:r>
+              <a:rPr lang="en-US" dirty="0"/>
+              <a:t>If this project was continued a data set with a larger sample size would be used. Also, the data set would need to include successful and unsuccessful movies to give us a more robust model.</a:t>
+            </a:r>
+          </a:p>
+          <a:p>
+            <a:endParaRPr lang="en-US" dirty="0"/>
+          </a:p>
+          <a:p>
+            <a:r>
+              <a:rPr lang="en-US" dirty="0"/>
+              <a:t>More features could be added or created as well, such as directors, production companies, cast, days of the week, </a:t>
+            </a:r>
+            <a:r>
+              <a:rPr lang="en-US" dirty="0" err="1"/>
+              <a:t>ect</a:t>
+            </a:r>
+            <a:r>
+              <a:rPr lang="en-US"/>
+              <a:t>.</a:t>
+            </a:r>
+          </a:p>
+        </p:txBody>
+      </p:sp>
+      <p:sp>
+        <p:nvSpPr>
+          <p:cNvPr id="4" name="Slide Number Placeholder 3"/>
+          <p:cNvSpPr>
+            <a:spLocks noGrp="1"/>
+          </p:cNvSpPr>
+          <p:nvPr>
+            <p:ph type="sldNum" sz="quarter" idx="5"/>
+          </p:nvPr>
+        </p:nvSpPr>
+        <p:spPr/>
+        <p:txBody>
+          <a:bodyPr/>
+          <a:lstStyle/>
+          <a:p>
+            <a:fld id="{AA0CCACE-AD26-4C7D-8D05-9EE2E6529D0E}" type="slidenum">
+              <a:rPr lang="en-US" smtClean="0"/>
+              <a:t>21</a:t>
+            </a:fld>
+            <a:endParaRPr lang="en-US"/>
+          </a:p>
+        </p:txBody>
+      </p:sp>
+    </p:spTree>
+    <p:extLst>
+      <p:ext uri="{BB962C8B-B14F-4D97-AF65-F5344CB8AC3E}">
+        <p14:creationId xmlns:p14="http://schemas.microsoft.com/office/powerpoint/2010/main" val="7876287"/>
+      </p:ext>
+    </p:extLst>
+  </p:cSld>
+  <p:clrMapOvr>
+    <a:masterClrMapping/>
+  </p:clrMapOvr>
+</p:notes>
+</file>
+
+<file path=ppt/notesSlides/notesSlide2.xml><?xml version="1.0" encoding="utf-8"?>
+<p:notes xmlns:a="http://schemas.openxmlformats.org/drawingml/2006/main" xmlns:r="http://schemas.openxmlformats.org/officeDocument/2006/relationships" xmlns:p="http://schemas.openxmlformats.org/presentationml/2006/main">
+  <p:cSld>
+    <p:spTree>
+      <p:nvGrpSpPr>
+        <p:cNvPr id="1" name=""/>
+        <p:cNvGrpSpPr/>
+        <p:nvPr/>
+      </p:nvGrpSpPr>
+      <p:grpSpPr>
+        <a:xfrm>
+          <a:off x="0" y="0"/>
+          <a:ext cx="0" cy="0"/>
+          <a:chOff x="0" y="0"/>
+          <a:chExt cx="0" cy="0"/>
+        </a:xfrm>
+      </p:grpSpPr>
+      <p:sp>
+        <p:nvSpPr>
+          <p:cNvPr id="2" name="Slide Image Placeholder 1"/>
+          <p:cNvSpPr>
+            <a:spLocks noGrp="1" noRot="1" noChangeAspect="1"/>
+          </p:cNvSpPr>
+          <p:nvPr>
+            <p:ph type="sldImg"/>
+          </p:nvPr>
+        </p:nvSpPr>
+        <p:spPr/>
+      </p:sp>
+      <p:sp>
+        <p:nvSpPr>
+          <p:cNvPr id="3" name="Notes Placeholder 2"/>
+          <p:cNvSpPr>
+            <a:spLocks noGrp="1"/>
+          </p:cNvSpPr>
+          <p:nvPr>
+            <p:ph type="body" idx="1"/>
+          </p:nvPr>
+        </p:nvSpPr>
+        <p:spPr/>
+        <p:txBody>
+          <a:bodyPr/>
+          <a:lstStyle/>
+          <a:p>
+            <a:r>
+              <a:rPr lang="en-US" dirty="0"/>
+              <a:t>Stake holders</a:t>
+            </a:r>
+          </a:p>
+          <a:p>
+            <a:r>
+              <a:rPr lang="en-US" dirty="0"/>
+              <a:t>Production companies</a:t>
+            </a:r>
+          </a:p>
+          <a:p>
+            <a:r>
+              <a:rPr lang="en-US" dirty="0"/>
+              <a:t>Actors</a:t>
+            </a:r>
+          </a:p>
+          <a:p>
+            <a:r>
+              <a:rPr lang="en-US" dirty="0"/>
+              <a:t>Theaters</a:t>
+            </a:r>
+          </a:p>
+          <a:p>
+            <a:r>
+              <a:rPr lang="en-US" dirty="0" err="1"/>
+              <a:t>Ect</a:t>
+            </a:r>
+            <a:r>
+              <a:rPr lang="en-US" dirty="0"/>
+              <a:t>.</a:t>
+            </a:r>
+          </a:p>
+        </p:txBody>
+      </p:sp>
+      <p:sp>
+        <p:nvSpPr>
+          <p:cNvPr id="4" name="Slide Number Placeholder 3"/>
+          <p:cNvSpPr>
+            <a:spLocks noGrp="1"/>
+          </p:cNvSpPr>
+          <p:nvPr>
+            <p:ph type="sldNum" sz="quarter" idx="5"/>
+          </p:nvPr>
+        </p:nvSpPr>
+        <p:spPr/>
+        <p:txBody>
+          <a:bodyPr/>
+          <a:lstStyle/>
+          <a:p>
+            <a:fld id="{AA0CCACE-AD26-4C7D-8D05-9EE2E6529D0E}" type="slidenum">
+              <a:rPr lang="en-US" smtClean="0"/>
+              <a:t>3</a:t>
+            </a:fld>
+            <a:endParaRPr lang="en-US"/>
+          </a:p>
+        </p:txBody>
+      </p:sp>
+    </p:spTree>
+    <p:extLst>
+      <p:ext uri="{BB962C8B-B14F-4D97-AF65-F5344CB8AC3E}">
+        <p14:creationId xmlns:p14="http://schemas.microsoft.com/office/powerpoint/2010/main" val="3141179041"/>
+      </p:ext>
+    </p:extLst>
+  </p:cSld>
+  <p:clrMapOvr>
+    <a:masterClrMapping/>
+  </p:clrMapOvr>
+</p:notes>
+</file>
+
+<file path=ppt/notesSlides/notesSlide3.xml><?xml version="1.0" encoding="utf-8"?>
+<p:notes xmlns:a="http://schemas.openxmlformats.org/drawingml/2006/main" xmlns:r="http://schemas.openxmlformats.org/officeDocument/2006/relationships" xmlns:p="http://schemas.openxmlformats.org/presentationml/2006/main">
+  <p:cSld>
+    <p:spTree>
+      <p:nvGrpSpPr>
+        <p:cNvPr id="1" name=""/>
+        <p:cNvGrpSpPr/>
+        <p:nvPr/>
+      </p:nvGrpSpPr>
+      <p:grpSpPr>
+        <a:xfrm>
+          <a:off x="0" y="0"/>
+          <a:ext cx="0" cy="0"/>
+          <a:chOff x="0" y="0"/>
+          <a:chExt cx="0" cy="0"/>
+        </a:xfrm>
+      </p:grpSpPr>
+      <p:sp>
+        <p:nvSpPr>
+          <p:cNvPr id="2" name="Slide Image Placeholder 1"/>
+          <p:cNvSpPr>
+            <a:spLocks noGrp="1" noRot="1" noChangeAspect="1"/>
+          </p:cNvSpPr>
+          <p:nvPr>
+            <p:ph type="sldImg"/>
+          </p:nvPr>
+        </p:nvSpPr>
+        <p:spPr/>
+      </p:sp>
+      <p:sp>
+        <p:nvSpPr>
+          <p:cNvPr id="3" name="Notes Placeholder 2"/>
+          <p:cNvSpPr>
+            <a:spLocks noGrp="1"/>
+          </p:cNvSpPr>
+          <p:nvPr>
+            <p:ph type="body" idx="1"/>
+          </p:nvPr>
+        </p:nvSpPr>
+        <p:spPr/>
+        <p:txBody>
+          <a:bodyPr/>
+          <a:lstStyle/>
+          <a:p>
+            <a:r>
+              <a:rPr lang="en-US" dirty="0"/>
+              <a:t>Features of this data set include:</a:t>
+            </a:r>
+          </a:p>
+          <a:p>
+            <a:pPr lvl="0"/>
+            <a:r>
+              <a:rPr lang="en-US" dirty="0"/>
+              <a:t>Title</a:t>
+            </a:r>
+          </a:p>
+          <a:p>
+            <a:pPr lvl="0"/>
+            <a:r>
+              <a:rPr lang="en-US" dirty="0"/>
+              <a:t>Release dates</a:t>
+            </a:r>
+          </a:p>
+          <a:p>
+            <a:pPr lvl="0"/>
+            <a:r>
+              <a:rPr lang="en-US" dirty="0"/>
+              <a:t>Budget</a:t>
+            </a:r>
+          </a:p>
+          <a:p>
+            <a:pPr lvl="0"/>
+            <a:r>
+              <a:rPr lang="en-US" dirty="0"/>
+              <a:t>Gross</a:t>
+            </a:r>
+          </a:p>
+          <a:p>
+            <a:pPr lvl="0"/>
+            <a:r>
+              <a:rPr lang="en-US" dirty="0"/>
+              <a:t>Genre</a:t>
+            </a:r>
+          </a:p>
+          <a:p>
+            <a:pPr lvl="0"/>
+            <a:r>
+              <a:rPr lang="en-US" dirty="0"/>
+              <a:t>Runtime</a:t>
+            </a:r>
+          </a:p>
+          <a:p>
+            <a:pPr lvl="0"/>
+            <a:r>
+              <a:rPr lang="en-US" dirty="0"/>
+              <a:t>MPAA rating</a:t>
+            </a:r>
+          </a:p>
+          <a:p>
+            <a:pPr lvl="0"/>
+            <a:r>
+              <a:rPr lang="en-US" dirty="0"/>
+              <a:t>Review ratings</a:t>
+            </a:r>
+          </a:p>
+          <a:p>
+            <a:pPr lvl="0"/>
+            <a:r>
+              <a:rPr lang="en-US" dirty="0"/>
+              <a:t>Number of Reviews</a:t>
+            </a:r>
+          </a:p>
+          <a:p>
+            <a:endParaRPr lang="en-US" dirty="0"/>
+          </a:p>
+        </p:txBody>
+      </p:sp>
+      <p:sp>
+        <p:nvSpPr>
+          <p:cNvPr id="4" name="Slide Number Placeholder 3"/>
+          <p:cNvSpPr>
+            <a:spLocks noGrp="1"/>
+          </p:cNvSpPr>
+          <p:nvPr>
+            <p:ph type="sldNum" sz="quarter" idx="5"/>
+          </p:nvPr>
+        </p:nvSpPr>
+        <p:spPr/>
+        <p:txBody>
+          <a:bodyPr/>
+          <a:lstStyle/>
+          <a:p>
+            <a:fld id="{AA0CCACE-AD26-4C7D-8D05-9EE2E6529D0E}" type="slidenum">
+              <a:rPr lang="en-US" smtClean="0"/>
+              <a:t>4</a:t>
+            </a:fld>
+            <a:endParaRPr lang="en-US"/>
+          </a:p>
+        </p:txBody>
+      </p:sp>
+    </p:spTree>
+    <p:extLst>
+      <p:ext uri="{BB962C8B-B14F-4D97-AF65-F5344CB8AC3E}">
+        <p14:creationId xmlns:p14="http://schemas.microsoft.com/office/powerpoint/2010/main" val="704001089"/>
+      </p:ext>
+    </p:extLst>
+  </p:cSld>
+  <p:clrMapOvr>
+    <a:masterClrMapping/>
+  </p:clrMapOvr>
+</p:notes>
+</file>
+
+<file path=ppt/notesSlides/notesSlide4.xml><?xml version="1.0" encoding="utf-8"?>
+<p:notes xmlns:a="http://schemas.openxmlformats.org/drawingml/2006/main" xmlns:r="http://schemas.openxmlformats.org/officeDocument/2006/relationships" xmlns:p="http://schemas.openxmlformats.org/presentationml/2006/main">
+  <p:cSld>
+    <p:spTree>
+      <p:nvGrpSpPr>
+        <p:cNvPr id="1" name=""/>
+        <p:cNvGrpSpPr/>
+        <p:nvPr/>
+      </p:nvGrpSpPr>
+      <p:grpSpPr>
+        <a:xfrm>
+          <a:off x="0" y="0"/>
+          <a:ext cx="0" cy="0"/>
+          <a:chOff x="0" y="0"/>
+          <a:chExt cx="0" cy="0"/>
+        </a:xfrm>
+      </p:grpSpPr>
+      <p:sp>
+        <p:nvSpPr>
+          <p:cNvPr id="2" name="Slide Image Placeholder 1"/>
+          <p:cNvSpPr>
+            <a:spLocks noGrp="1" noRot="1" noChangeAspect="1"/>
+          </p:cNvSpPr>
+          <p:nvPr>
+            <p:ph type="sldImg"/>
+          </p:nvPr>
+        </p:nvSpPr>
+        <p:spPr/>
+      </p:sp>
+      <p:sp>
+        <p:nvSpPr>
+          <p:cNvPr id="3" name="Notes Placeholder 2"/>
+          <p:cNvSpPr>
+            <a:spLocks noGrp="1"/>
+          </p:cNvSpPr>
+          <p:nvPr>
+            <p:ph type="body" idx="1"/>
+          </p:nvPr>
+        </p:nvSpPr>
+        <p:spPr/>
+        <p:txBody>
+          <a:bodyPr/>
+          <a:lstStyle/>
+          <a:p>
+            <a:r>
+              <a:rPr lang="en-US" dirty="0"/>
+              <a:t>The graph shows Gross profit of movies by year. Each year spans the minimum and maximum gross profit. You can see the fist spike is Titanic which is above 1.5 billion. Avatar is the second spike at over 2.5 billion.</a:t>
+            </a:r>
+          </a:p>
+        </p:txBody>
+      </p:sp>
+      <p:sp>
+        <p:nvSpPr>
+          <p:cNvPr id="4" name="Slide Number Placeholder 3"/>
+          <p:cNvSpPr>
+            <a:spLocks noGrp="1"/>
+          </p:cNvSpPr>
+          <p:nvPr>
+            <p:ph type="sldNum" sz="quarter" idx="5"/>
+          </p:nvPr>
+        </p:nvSpPr>
+        <p:spPr/>
+        <p:txBody>
+          <a:bodyPr/>
+          <a:lstStyle/>
+          <a:p>
+            <a:fld id="{AA0CCACE-AD26-4C7D-8D05-9EE2E6529D0E}" type="slidenum">
+              <a:rPr lang="en-US" smtClean="0"/>
+              <a:t>5</a:t>
+            </a:fld>
+            <a:endParaRPr lang="en-US"/>
+          </a:p>
+        </p:txBody>
+      </p:sp>
+    </p:spTree>
+    <p:extLst>
+      <p:ext uri="{BB962C8B-B14F-4D97-AF65-F5344CB8AC3E}">
+        <p14:creationId xmlns:p14="http://schemas.microsoft.com/office/powerpoint/2010/main" val="2950763233"/>
+      </p:ext>
+    </p:extLst>
+  </p:cSld>
+  <p:clrMapOvr>
+    <a:masterClrMapping/>
+  </p:clrMapOvr>
+</p:notes>
+</file>
+
+<file path=ppt/notesSlides/notesSlide5.xml><?xml version="1.0" encoding="utf-8"?>
+<p:notes xmlns:a="http://schemas.openxmlformats.org/drawingml/2006/main" xmlns:r="http://schemas.openxmlformats.org/officeDocument/2006/relationships" xmlns:p="http://schemas.openxmlformats.org/presentationml/2006/main">
+  <p:cSld>
+    <p:spTree>
+      <p:nvGrpSpPr>
+        <p:cNvPr id="1" name=""/>
+        <p:cNvGrpSpPr/>
+        <p:nvPr/>
+      </p:nvGrpSpPr>
+      <p:grpSpPr>
+        <a:xfrm>
+          <a:off x="0" y="0"/>
+          <a:ext cx="0" cy="0"/>
+          <a:chOff x="0" y="0"/>
+          <a:chExt cx="0" cy="0"/>
+        </a:xfrm>
+      </p:grpSpPr>
+      <p:sp>
+        <p:nvSpPr>
+          <p:cNvPr id="2" name="Slide Image Placeholder 1"/>
+          <p:cNvSpPr>
+            <a:spLocks noGrp="1" noRot="1" noChangeAspect="1"/>
+          </p:cNvSpPr>
+          <p:nvPr>
+            <p:ph type="sldImg"/>
+          </p:nvPr>
+        </p:nvSpPr>
+        <p:spPr/>
+      </p:sp>
+      <p:sp>
+        <p:nvSpPr>
+          <p:cNvPr id="3" name="Notes Placeholder 2"/>
+          <p:cNvSpPr>
+            <a:spLocks noGrp="1"/>
+          </p:cNvSpPr>
+          <p:nvPr>
+            <p:ph type="body" idx="1"/>
+          </p:nvPr>
+        </p:nvSpPr>
+        <p:spPr/>
+        <p:txBody>
+          <a:bodyPr/>
+          <a:lstStyle/>
+          <a:p>
+            <a:r>
+              <a:rPr lang="en-US" dirty="0"/>
+              <a:t>The Genre distribution of this data set does not sample equally from all genres, this can cause bias towards the respective genres affected. Comedy, action, animation and drama are over represented when compared to the other genres.</a:t>
+            </a:r>
+          </a:p>
+        </p:txBody>
+      </p:sp>
+      <p:sp>
+        <p:nvSpPr>
+          <p:cNvPr id="4" name="Slide Number Placeholder 3"/>
+          <p:cNvSpPr>
+            <a:spLocks noGrp="1"/>
+          </p:cNvSpPr>
+          <p:nvPr>
+            <p:ph type="sldNum" sz="quarter" idx="5"/>
+          </p:nvPr>
+        </p:nvSpPr>
+        <p:spPr/>
+        <p:txBody>
+          <a:bodyPr/>
+          <a:lstStyle/>
+          <a:p>
+            <a:fld id="{AA0CCACE-AD26-4C7D-8D05-9EE2E6529D0E}" type="slidenum">
+              <a:rPr lang="en-US" smtClean="0"/>
+              <a:t>7</a:t>
+            </a:fld>
+            <a:endParaRPr lang="en-US"/>
+          </a:p>
+        </p:txBody>
+      </p:sp>
+    </p:spTree>
+    <p:extLst>
+      <p:ext uri="{BB962C8B-B14F-4D97-AF65-F5344CB8AC3E}">
+        <p14:creationId xmlns:p14="http://schemas.microsoft.com/office/powerpoint/2010/main" val="982885815"/>
+      </p:ext>
+    </p:extLst>
+  </p:cSld>
+  <p:clrMapOvr>
+    <a:masterClrMapping/>
+  </p:clrMapOvr>
+</p:notes>
+</file>
+
+<file path=ppt/notesSlides/notesSlide6.xml><?xml version="1.0" encoding="utf-8"?>
+<p:notes xmlns:a="http://schemas.openxmlformats.org/drawingml/2006/main" xmlns:r="http://schemas.openxmlformats.org/officeDocument/2006/relationships" xmlns:p="http://schemas.openxmlformats.org/presentationml/2006/main">
+  <p:cSld>
+    <p:spTree>
+      <p:nvGrpSpPr>
+        <p:cNvPr id="1" name=""/>
+        <p:cNvGrpSpPr/>
+        <p:nvPr/>
+      </p:nvGrpSpPr>
+      <p:grpSpPr>
+        <a:xfrm>
+          <a:off x="0" y="0"/>
+          <a:ext cx="0" cy="0"/>
+          <a:chOff x="0" y="0"/>
+          <a:chExt cx="0" cy="0"/>
+        </a:xfrm>
+      </p:grpSpPr>
+      <p:sp>
+        <p:nvSpPr>
+          <p:cNvPr id="2" name="Slide Image Placeholder 1"/>
+          <p:cNvSpPr>
+            <a:spLocks noGrp="1" noRot="1" noChangeAspect="1"/>
+          </p:cNvSpPr>
+          <p:nvPr>
+            <p:ph type="sldImg"/>
+          </p:nvPr>
+        </p:nvSpPr>
+        <p:spPr/>
+      </p:sp>
+      <p:sp>
+        <p:nvSpPr>
+          <p:cNvPr id="3" name="Notes Placeholder 2"/>
+          <p:cNvSpPr>
+            <a:spLocks noGrp="1"/>
+          </p:cNvSpPr>
+          <p:nvPr>
+            <p:ph type="body" idx="1"/>
+          </p:nvPr>
+        </p:nvSpPr>
+        <p:spPr/>
+        <p:txBody>
+          <a:bodyPr/>
+          <a:lstStyle/>
+          <a:p>
+            <a:r>
+              <a:rPr lang="en-US" dirty="0"/>
+              <a:t>This boxplot shows movies’ net profit (USD in Billions) groped by genre. Avatar and the Titanic were removed from the data set due to being outliers. You can see Avatar as an outlier in the adventure genre and Titanic as a n outlier in the romance genre. The Net Profit of the genres are relatively similar.</a:t>
+            </a:r>
+          </a:p>
+        </p:txBody>
+      </p:sp>
+      <p:sp>
+        <p:nvSpPr>
+          <p:cNvPr id="4" name="Slide Number Placeholder 3"/>
+          <p:cNvSpPr>
+            <a:spLocks noGrp="1"/>
+          </p:cNvSpPr>
+          <p:nvPr>
+            <p:ph type="sldNum" sz="quarter" idx="5"/>
+          </p:nvPr>
+        </p:nvSpPr>
+        <p:spPr/>
+        <p:txBody>
+          <a:bodyPr/>
+          <a:lstStyle/>
+          <a:p>
+            <a:fld id="{AA0CCACE-AD26-4C7D-8D05-9EE2E6529D0E}" type="slidenum">
+              <a:rPr lang="en-US" smtClean="0"/>
+              <a:t>8</a:t>
+            </a:fld>
+            <a:endParaRPr lang="en-US"/>
+          </a:p>
+        </p:txBody>
+      </p:sp>
+    </p:spTree>
+    <p:extLst>
+      <p:ext uri="{BB962C8B-B14F-4D97-AF65-F5344CB8AC3E}">
+        <p14:creationId xmlns:p14="http://schemas.microsoft.com/office/powerpoint/2010/main" val="1473345517"/>
+      </p:ext>
+    </p:extLst>
+  </p:cSld>
+  <p:clrMapOvr>
+    <a:masterClrMapping/>
+  </p:clrMapOvr>
+</p:notes>
+</file>
+
+<file path=ppt/notesSlides/notesSlide7.xml><?xml version="1.0" encoding="utf-8"?>
+<p:notes xmlns:a="http://schemas.openxmlformats.org/drawingml/2006/main" xmlns:r="http://schemas.openxmlformats.org/officeDocument/2006/relationships" xmlns:p="http://schemas.openxmlformats.org/presentationml/2006/main">
+  <p:cSld>
+    <p:spTree>
+      <p:nvGrpSpPr>
+        <p:cNvPr id="1" name=""/>
+        <p:cNvGrpSpPr/>
+        <p:nvPr/>
+      </p:nvGrpSpPr>
+      <p:grpSpPr>
+        <a:xfrm>
+          <a:off x="0" y="0"/>
+          <a:ext cx="0" cy="0"/>
+          <a:chOff x="0" y="0"/>
+          <a:chExt cx="0" cy="0"/>
+        </a:xfrm>
+      </p:grpSpPr>
+      <p:sp>
+        <p:nvSpPr>
+          <p:cNvPr id="2" name="Slide Image Placeholder 1"/>
+          <p:cNvSpPr>
+            <a:spLocks noGrp="1" noRot="1" noChangeAspect="1"/>
+          </p:cNvSpPr>
+          <p:nvPr>
+            <p:ph type="sldImg"/>
+          </p:nvPr>
+        </p:nvSpPr>
+        <p:spPr/>
+      </p:sp>
+      <p:sp>
+        <p:nvSpPr>
+          <p:cNvPr id="3" name="Notes Placeholder 2"/>
+          <p:cNvSpPr>
+            <a:spLocks noGrp="1"/>
+          </p:cNvSpPr>
+          <p:nvPr>
+            <p:ph type="body" idx="1"/>
+          </p:nvPr>
+        </p:nvSpPr>
+        <p:spPr/>
+        <p:txBody>
+          <a:bodyPr/>
+          <a:lstStyle/>
+          <a:p>
+            <a:r>
+              <a:rPr lang="en-US" dirty="0"/>
+              <a:t>This boxplot shows movies’ return on investment (ROI) grouped by genre. ROI was calculated by taking the Net Profit/Budget. The Blair Witch Project was removed from the data set as an outlier because it had an ROI of 4132. My Big Fat Greek Wedding had the next highest ROI at 75. It is important to note that successful low budget movies will always return the highest ROIs. A low budget movie is a lower risk of investment and a higher chance for a bigger return.</a:t>
+            </a:r>
+          </a:p>
+        </p:txBody>
+      </p:sp>
+      <p:sp>
+        <p:nvSpPr>
+          <p:cNvPr id="4" name="Slide Number Placeholder 3"/>
+          <p:cNvSpPr>
+            <a:spLocks noGrp="1"/>
+          </p:cNvSpPr>
+          <p:nvPr>
+            <p:ph type="sldNum" sz="quarter" idx="5"/>
+          </p:nvPr>
+        </p:nvSpPr>
+        <p:spPr/>
+        <p:txBody>
+          <a:bodyPr/>
+          <a:lstStyle/>
+          <a:p>
+            <a:fld id="{AA0CCACE-AD26-4C7D-8D05-9EE2E6529D0E}" type="slidenum">
+              <a:rPr lang="en-US" smtClean="0"/>
+              <a:t>9</a:t>
+            </a:fld>
+            <a:endParaRPr lang="en-US"/>
+          </a:p>
+        </p:txBody>
+      </p:sp>
+    </p:spTree>
+    <p:extLst>
+      <p:ext uri="{BB962C8B-B14F-4D97-AF65-F5344CB8AC3E}">
+        <p14:creationId xmlns:p14="http://schemas.microsoft.com/office/powerpoint/2010/main" val="2750780729"/>
+      </p:ext>
+    </p:extLst>
+  </p:cSld>
+  <p:clrMapOvr>
+    <a:masterClrMapping/>
+  </p:clrMapOvr>
+</p:notes>
+</file>
+
+<file path=ppt/notesSlides/notesSlide8.xml><?xml version="1.0" encoding="utf-8"?>
+<p:notes xmlns:a="http://schemas.openxmlformats.org/drawingml/2006/main" xmlns:r="http://schemas.openxmlformats.org/officeDocument/2006/relationships" xmlns:p="http://schemas.openxmlformats.org/presentationml/2006/main">
+  <p:cSld>
+    <p:spTree>
+      <p:nvGrpSpPr>
+        <p:cNvPr id="1" name=""/>
+        <p:cNvGrpSpPr/>
+        <p:nvPr/>
+      </p:nvGrpSpPr>
+      <p:grpSpPr>
+        <a:xfrm>
+          <a:off x="0" y="0"/>
+          <a:ext cx="0" cy="0"/>
+          <a:chOff x="0" y="0"/>
+          <a:chExt cx="0" cy="0"/>
+        </a:xfrm>
+      </p:grpSpPr>
+      <p:sp>
+        <p:nvSpPr>
+          <p:cNvPr id="2" name="Slide Image Placeholder 1"/>
+          <p:cNvSpPr>
+            <a:spLocks noGrp="1" noRot="1" noChangeAspect="1"/>
+          </p:cNvSpPr>
+          <p:nvPr>
+            <p:ph type="sldImg"/>
+          </p:nvPr>
+        </p:nvSpPr>
+        <p:spPr/>
+      </p:sp>
+      <p:sp>
+        <p:nvSpPr>
+          <p:cNvPr id="3" name="Notes Placeholder 2"/>
+          <p:cNvSpPr>
+            <a:spLocks noGrp="1"/>
+          </p:cNvSpPr>
+          <p:nvPr>
+            <p:ph type="body" idx="1"/>
+          </p:nvPr>
+        </p:nvSpPr>
+        <p:spPr/>
+        <p:txBody>
+          <a:bodyPr/>
+          <a:lstStyle/>
+          <a:p>
+            <a:r>
+              <a:rPr lang="en-US" dirty="0"/>
+              <a:t>This Boxplot shows movies’ net profit in USD billions grouped by MPAA Rating. You can see PG-13 has the highest net profits. So PG-13 movies have the highest chance of the best return in net profit. R movies have the lowest net profits.</a:t>
+            </a:r>
+          </a:p>
+        </p:txBody>
+      </p:sp>
+      <p:sp>
+        <p:nvSpPr>
+          <p:cNvPr id="4" name="Slide Number Placeholder 3"/>
+          <p:cNvSpPr>
+            <a:spLocks noGrp="1"/>
+          </p:cNvSpPr>
+          <p:nvPr>
+            <p:ph type="sldNum" sz="quarter" idx="5"/>
+          </p:nvPr>
+        </p:nvSpPr>
+        <p:spPr/>
+        <p:txBody>
+          <a:bodyPr/>
+          <a:lstStyle/>
+          <a:p>
+            <a:fld id="{AA0CCACE-AD26-4C7D-8D05-9EE2E6529D0E}" type="slidenum">
+              <a:rPr lang="en-US" smtClean="0"/>
+              <a:t>10</a:t>
+            </a:fld>
+            <a:endParaRPr lang="en-US"/>
+          </a:p>
+        </p:txBody>
+      </p:sp>
+    </p:spTree>
+    <p:extLst>
+      <p:ext uri="{BB962C8B-B14F-4D97-AF65-F5344CB8AC3E}">
+        <p14:creationId xmlns:p14="http://schemas.microsoft.com/office/powerpoint/2010/main" val="3071419103"/>
+      </p:ext>
+    </p:extLst>
+  </p:cSld>
+  <p:clrMapOvr>
+    <a:masterClrMapping/>
+  </p:clrMapOvr>
+</p:notes>
+</file>
+
+<file path=ppt/notesSlides/notesSlide9.xml><?xml version="1.0" encoding="utf-8"?>
+<p:notes xmlns:a="http://schemas.openxmlformats.org/drawingml/2006/main" xmlns:r="http://schemas.openxmlformats.org/officeDocument/2006/relationships" xmlns:p="http://schemas.openxmlformats.org/presentationml/2006/main">
+  <p:cSld>
+    <p:spTree>
+      <p:nvGrpSpPr>
+        <p:cNvPr id="1" name=""/>
+        <p:cNvGrpSpPr/>
+        <p:nvPr/>
+      </p:nvGrpSpPr>
+      <p:grpSpPr>
+        <a:xfrm>
+          <a:off x="0" y="0"/>
+          <a:ext cx="0" cy="0"/>
+          <a:chOff x="0" y="0"/>
+          <a:chExt cx="0" cy="0"/>
+        </a:xfrm>
+      </p:grpSpPr>
+      <p:sp>
+        <p:nvSpPr>
+          <p:cNvPr id="2" name="Slide Image Placeholder 1"/>
+          <p:cNvSpPr>
+            <a:spLocks noGrp="1" noRot="1" noChangeAspect="1"/>
+          </p:cNvSpPr>
+          <p:nvPr>
+            <p:ph type="sldImg"/>
+          </p:nvPr>
+        </p:nvSpPr>
+        <p:spPr/>
+      </p:sp>
+      <p:sp>
+        <p:nvSpPr>
+          <p:cNvPr id="3" name="Notes Placeholder 2"/>
+          <p:cNvSpPr>
+            <a:spLocks noGrp="1"/>
+          </p:cNvSpPr>
+          <p:nvPr>
+            <p:ph type="body" idx="1"/>
+          </p:nvPr>
+        </p:nvSpPr>
+        <p:spPr/>
+        <p:txBody>
+          <a:bodyPr/>
+          <a:lstStyle/>
+          <a:p>
+            <a:r>
+              <a:rPr lang="en-US" dirty="0"/>
+              <a:t>This Boxplot shows movies’ ROI grouped by MPAA Ratings. It shows that PG-13 and R movies have the best ROIs.</a:t>
+            </a:r>
+          </a:p>
+        </p:txBody>
+      </p:sp>
+      <p:sp>
+        <p:nvSpPr>
+          <p:cNvPr id="4" name="Slide Number Placeholder 3"/>
+          <p:cNvSpPr>
+            <a:spLocks noGrp="1"/>
+          </p:cNvSpPr>
+          <p:nvPr>
+            <p:ph type="sldNum" sz="quarter" idx="5"/>
+          </p:nvPr>
+        </p:nvSpPr>
+        <p:spPr/>
+        <p:txBody>
+          <a:bodyPr/>
+          <a:lstStyle/>
+          <a:p>
+            <a:fld id="{AA0CCACE-AD26-4C7D-8D05-9EE2E6529D0E}" type="slidenum">
+              <a:rPr lang="en-US" smtClean="0"/>
+              <a:t>11</a:t>
+            </a:fld>
+            <a:endParaRPr lang="en-US"/>
+          </a:p>
+        </p:txBody>
+      </p:sp>
+    </p:spTree>
+    <p:extLst>
+      <p:ext uri="{BB962C8B-B14F-4D97-AF65-F5344CB8AC3E}">
+        <p14:creationId xmlns:p14="http://schemas.microsoft.com/office/powerpoint/2010/main" val="3975079546"/>
+      </p:ext>
+    </p:extLst>
+  </p:cSld>
+  <p:clrMapOvr>
+    <a:masterClrMapping/>
+  </p:clrMapOvr>
+</p:notes>
+</file>
+
 <file path=ppt/slideLayouts/slideLayout1.xml><?xml version="1.0" encoding="utf-8"?>
 <p:sldLayout xmlns:a="http://schemas.openxmlformats.org/drawingml/2006/main" xmlns:r="http://schemas.openxmlformats.org/officeDocument/2006/relationships" xmlns:p="http://schemas.openxmlformats.org/presentationml/2006/main" type="title" preserve="1">
   <p:cSld name="Title Slide">
@@ -15526,7 +17781,7 @@
           <a:p>
             <a:fld id="{828E932C-EB48-4843-B8CE-93B895712901}" type="datetimeFigureOut">
               <a:rPr lang="en-US" smtClean="0"/>
-              <a:t>8/24/2025</a:t>
+              <a:t>8/28/2025</a:t>
             </a:fld>
             <a:endParaRPr lang="en-US"/>
           </a:p>
@@ -15724,7 +17979,7 @@
           <a:p>
             <a:fld id="{828E932C-EB48-4843-B8CE-93B895712901}" type="datetimeFigureOut">
               <a:rPr lang="en-US" smtClean="0"/>
-              <a:t>8/24/2025</a:t>
+              <a:t>8/28/2025</a:t>
             </a:fld>
             <a:endParaRPr lang="en-US"/>
           </a:p>
@@ -15932,7 +18187,7 @@
           <a:p>
             <a:fld id="{828E932C-EB48-4843-B8CE-93B895712901}" type="datetimeFigureOut">
               <a:rPr lang="en-US" smtClean="0"/>
-              <a:t>8/24/2025</a:t>
+              <a:t>8/28/2025</a:t>
             </a:fld>
             <a:endParaRPr lang="en-US"/>
           </a:p>
@@ -16130,7 +18385,7 @@
           <a:p>
             <a:fld id="{828E932C-EB48-4843-B8CE-93B895712901}" type="datetimeFigureOut">
               <a:rPr lang="en-US" smtClean="0"/>
-              <a:t>8/24/2025</a:t>
+              <a:t>8/28/2025</a:t>
             </a:fld>
             <a:endParaRPr lang="en-US"/>
           </a:p>
@@ -16405,7 +18660,7 @@
           <a:p>
             <a:fld id="{828E932C-EB48-4843-B8CE-93B895712901}" type="datetimeFigureOut">
               <a:rPr lang="en-US" smtClean="0"/>
-              <a:t>8/24/2025</a:t>
+              <a:t>8/28/2025</a:t>
             </a:fld>
             <a:endParaRPr lang="en-US"/>
           </a:p>
@@ -16670,7 +18925,7 @@
           <a:p>
             <a:fld id="{828E932C-EB48-4843-B8CE-93B895712901}" type="datetimeFigureOut">
               <a:rPr lang="en-US" smtClean="0"/>
-              <a:t>8/24/2025</a:t>
+              <a:t>8/28/2025</a:t>
             </a:fld>
             <a:endParaRPr lang="en-US"/>
           </a:p>
@@ -17082,7 +19337,7 @@
           <a:p>
             <a:fld id="{828E932C-EB48-4843-B8CE-93B895712901}" type="datetimeFigureOut">
               <a:rPr lang="en-US" smtClean="0"/>
-              <a:t>8/24/2025</a:t>
+              <a:t>8/28/2025</a:t>
             </a:fld>
             <a:endParaRPr lang="en-US"/>
           </a:p>
@@ -17223,7 +19478,7 @@
           <a:p>
             <a:fld id="{828E932C-EB48-4843-B8CE-93B895712901}" type="datetimeFigureOut">
               <a:rPr lang="en-US" smtClean="0"/>
-              <a:t>8/24/2025</a:t>
+              <a:t>8/28/2025</a:t>
             </a:fld>
             <a:endParaRPr lang="en-US"/>
           </a:p>
@@ -17336,7 +19591,7 @@
           <a:p>
             <a:fld id="{828E932C-EB48-4843-B8CE-93B895712901}" type="datetimeFigureOut">
               <a:rPr lang="en-US" smtClean="0"/>
-              <a:t>8/24/2025</a:t>
+              <a:t>8/28/2025</a:t>
             </a:fld>
             <a:endParaRPr lang="en-US"/>
           </a:p>
@@ -17647,7 +19902,7 @@
           <a:p>
             <a:fld id="{828E932C-EB48-4843-B8CE-93B895712901}" type="datetimeFigureOut">
               <a:rPr lang="en-US" smtClean="0"/>
-              <a:t>8/24/2025</a:t>
+              <a:t>8/28/2025</a:t>
             </a:fld>
             <a:endParaRPr lang="en-US"/>
           </a:p>
@@ -17935,7 +20190,7 @@
           <a:p>
             <a:fld id="{828E932C-EB48-4843-B8CE-93B895712901}" type="datetimeFigureOut">
               <a:rPr lang="en-US" smtClean="0"/>
-              <a:t>8/24/2025</a:t>
+              <a:t>8/28/2025</a:t>
             </a:fld>
             <a:endParaRPr lang="en-US"/>
           </a:p>
@@ -18176,7 +20431,7 @@
           <a:p>
             <a:fld id="{828E932C-EB48-4843-B8CE-93B895712901}" type="datetimeFigureOut">
               <a:rPr lang="en-US" smtClean="0"/>
-              <a:t>8/24/2025</a:t>
+              <a:t>8/28/2025</a:t>
             </a:fld>
             <a:endParaRPr lang="en-US"/>
           </a:p>
@@ -19752,7 +22007,7 @@
           </p:nvPr>
         </p:nvPicPr>
         <p:blipFill>
-          <a:blip r:embed="rId2"/>
+          <a:blip r:embed="rId3"/>
           <a:stretch>
             <a:fillRect/>
           </a:stretch>
@@ -20337,7 +22592,7 @@
           </p:nvPr>
         </p:nvPicPr>
         <p:blipFill>
-          <a:blip r:embed="rId2"/>
+          <a:blip r:embed="rId3"/>
           <a:stretch>
             <a:fillRect/>
           </a:stretch>
@@ -20996,7 +23251,7 @@
           </p:nvPr>
         </p:nvPicPr>
         <p:blipFill>
-          <a:blip r:embed="rId2"/>
+          <a:blip r:embed="rId3"/>
           <a:stretch>
             <a:fillRect/>
           </a:stretch>
@@ -21551,7 +23806,7 @@
           <p:nvPr/>
         </p:nvPicPr>
         <p:blipFill>
-          <a:blip r:embed="rId2"/>
+          <a:blip r:embed="rId3"/>
           <a:stretch>
             <a:fillRect/>
           </a:stretch>
@@ -21581,7 +23836,7 @@
           <p:nvPr/>
         </p:nvPicPr>
         <p:blipFill>
-          <a:blip r:embed="rId3"/>
+          <a:blip r:embed="rId4"/>
           <a:stretch>
             <a:fillRect/>
           </a:stretch>
@@ -21994,7 +24249,7 @@
           <p:nvPr/>
         </p:nvPicPr>
         <p:blipFill>
-          <a:blip r:embed="rId2"/>
+          <a:blip r:embed="rId3"/>
           <a:stretch>
             <a:fillRect/>
           </a:stretch>
@@ -22407,7 +24662,7 @@
           <p:nvPr/>
         </p:nvPicPr>
         <p:blipFill>
-          <a:blip r:embed="rId2"/>
+          <a:blip r:embed="rId3"/>
           <a:stretch>
             <a:fillRect/>
           </a:stretch>
@@ -22838,7 +25093,7 @@
           </p:nvPr>
         </p:nvPicPr>
         <p:blipFill>
-          <a:blip r:embed="rId2"/>
+          <a:blip r:embed="rId3"/>
           <a:stretch>
             <a:fillRect/>
           </a:stretch>
@@ -23904,7 +26159,7 @@
         </p:xfrm>
         <a:graphic>
           <a:graphicData uri="http://schemas.openxmlformats.org/drawingml/2006/diagram">
-            <dgm:relIds xmlns:dgm="http://schemas.openxmlformats.org/drawingml/2006/diagram" xmlns:r="http://schemas.openxmlformats.org/officeDocument/2006/relationships" r:dm="rId2" r:lo="rId3" r:qs="rId4" r:cs="rId5"/>
+            <dgm:relIds xmlns:dgm="http://schemas.openxmlformats.org/drawingml/2006/diagram" xmlns:r="http://schemas.openxmlformats.org/officeDocument/2006/relationships" r:dm="rId3" r:lo="rId4" r:qs="rId5" r:cs="rId6"/>
           </a:graphicData>
         </a:graphic>
       </p:graphicFrame>
@@ -25715,7 +27970,7 @@
           <p:nvPr/>
         </p:nvPicPr>
         <p:blipFill>
-          <a:blip r:embed="rId2"/>
+          <a:blip r:embed="rId3"/>
           <a:stretch>
             <a:fillRect/>
           </a:stretch>
@@ -25745,7 +28000,7 @@
           <p:nvPr/>
         </p:nvPicPr>
         <p:blipFill>
-          <a:blip r:embed="rId3"/>
+          <a:blip r:embed="rId4"/>
           <a:stretch>
             <a:fillRect/>
           </a:stretch>
@@ -26448,14 +28703,7 @@
               <a:buNone/>
             </a:pPr>
             <a:r>
-              <a:rPr lang="en-US" sz="2400" kern="1200">
-                <a:solidFill>
-                  <a:schemeClr val="tx1"/>
-                </a:solidFill>
-                <a:latin typeface="+mn-lt"/>
-                <a:ea typeface="+mn-ea"/>
-                <a:cs typeface="+mn-cs"/>
-              </a:rPr>
+              <a:rPr lang="en-US" sz="2400" dirty="0"/>
               <a:t>When investing in a movie, how do you know if it will be successful or a flop?</a:t>
             </a:r>
           </a:p>
@@ -27125,7 +29373,7 @@
           <a:p>
             <a:r>
               <a:rPr lang="en-US" sz="1700" dirty="0"/>
-              <a:t>Movies released in the June-August or November-December are more successful.</a:t>
+              <a:t>Movies released in the May-July or November-December are more successful.</a:t>
             </a:r>
           </a:p>
           <a:p>
@@ -27827,7 +30075,7 @@
         </p:xfrm>
         <a:graphic>
           <a:graphicData uri="http://schemas.openxmlformats.org/drawingml/2006/diagram">
-            <dgm:relIds xmlns:dgm="http://schemas.openxmlformats.org/drawingml/2006/diagram" xmlns:r="http://schemas.openxmlformats.org/officeDocument/2006/relationships" r:dm="rId2" r:lo="rId3" r:qs="rId4" r:cs="rId5"/>
+            <dgm:relIds xmlns:dgm="http://schemas.openxmlformats.org/drawingml/2006/diagram" xmlns:r="http://schemas.openxmlformats.org/officeDocument/2006/relationships" r:dm="rId3" r:lo="rId4" r:qs="rId5" r:cs="rId6"/>
           </a:graphicData>
         </a:graphic>
       </p:graphicFrame>
@@ -28238,7 +30486,7 @@
         </p:xfrm>
         <a:graphic>
           <a:graphicData uri="http://schemas.openxmlformats.org/drawingml/2006/diagram">
-            <dgm:relIds xmlns:dgm="http://schemas.openxmlformats.org/drawingml/2006/diagram" xmlns:r="http://schemas.openxmlformats.org/officeDocument/2006/relationships" r:dm="rId2" r:lo="rId3" r:qs="rId4" r:cs="rId5"/>
+            <dgm:relIds xmlns:dgm="http://schemas.openxmlformats.org/drawingml/2006/diagram" xmlns:r="http://schemas.openxmlformats.org/officeDocument/2006/relationships" r:dm="rId3" r:lo="rId4" r:qs="rId5" r:cs="rId6"/>
           </a:graphicData>
         </a:graphic>
       </p:graphicFrame>
@@ -28648,7 +30896,7 @@
         </p:xfrm>
         <a:graphic>
           <a:graphicData uri="http://schemas.openxmlformats.org/drawingml/2006/diagram">
-            <dgm:relIds xmlns:dgm="http://schemas.openxmlformats.org/drawingml/2006/diagram" xmlns:r="http://schemas.openxmlformats.org/officeDocument/2006/relationships" r:dm="rId2" r:lo="rId3" r:qs="rId4" r:cs="rId5"/>
+            <dgm:relIds xmlns:dgm="http://schemas.openxmlformats.org/drawingml/2006/diagram" xmlns:r="http://schemas.openxmlformats.org/officeDocument/2006/relationships" r:dm="rId3" r:lo="rId4" r:qs="rId5" r:cs="rId6"/>
           </a:graphicData>
         </a:graphic>
       </p:graphicFrame>
@@ -28740,7 +30988,7 @@
           <p:nvPr/>
         </p:nvPicPr>
         <p:blipFill>
-          <a:blip r:embed="rId2"/>
+          <a:blip r:embed="rId3"/>
           <a:stretch>
             <a:fillRect/>
           </a:stretch>
@@ -28959,10 +31207,80 @@
         </p:xfrm>
         <a:graphic>
           <a:graphicData uri="http://schemas.openxmlformats.org/drawingml/2006/diagram">
-            <dgm:relIds xmlns:dgm="http://schemas.openxmlformats.org/drawingml/2006/diagram" xmlns:r="http://schemas.openxmlformats.org/officeDocument/2006/relationships" r:dm="rId3" r:lo="rId4" r:qs="rId5" r:cs="rId6"/>
+            <dgm:relIds xmlns:dgm="http://schemas.openxmlformats.org/drawingml/2006/diagram" xmlns:r="http://schemas.openxmlformats.org/officeDocument/2006/relationships" r:dm="rId4" r:lo="rId5" r:qs="rId6" r:cs="rId7"/>
           </a:graphicData>
         </a:graphic>
       </p:graphicFrame>
+      <p:sp>
+        <p:nvSpPr>
+          <p:cNvPr id="3" name="TextBox 2">
+            <a:extLst>
+              <a:ext uri="{FF2B5EF4-FFF2-40B4-BE49-F238E27FC236}">
+                <a16:creationId xmlns:a16="http://schemas.microsoft.com/office/drawing/2014/main" id="{ABCCD861-12EB-897B-2D50-020161A0D9B7}"/>
+              </a:ext>
+            </a:extLst>
+          </p:cNvPr>
+          <p:cNvSpPr txBox="1"/>
+          <p:nvPr/>
+        </p:nvSpPr>
+        <p:spPr>
+          <a:xfrm rot="16200000">
+            <a:off x="4710439" y="2133600"/>
+            <a:ext cx="889000" cy="261610"/>
+          </a:xfrm>
+          <a:prstGeom prst="rect">
+            <a:avLst/>
+          </a:prstGeom>
+          <a:noFill/>
+        </p:spPr>
+        <p:txBody>
+          <a:bodyPr wrap="square" rtlCol="0">
+            <a:spAutoFit/>
+          </a:bodyPr>
+          <a:lstStyle/>
+          <a:p>
+            <a:r>
+              <a:rPr lang="en-US" sz="1100" dirty="0"/>
+              <a:t>Billion</a:t>
+            </a:r>
+          </a:p>
+        </p:txBody>
+      </p:sp>
+      <p:sp>
+        <p:nvSpPr>
+          <p:cNvPr id="4" name="TextBox 3">
+            <a:extLst>
+              <a:ext uri="{FF2B5EF4-FFF2-40B4-BE49-F238E27FC236}">
+                <a16:creationId xmlns:a16="http://schemas.microsoft.com/office/drawing/2014/main" id="{86321FDF-2C60-807F-A2B9-8121AA63B3EE}"/>
+              </a:ext>
+            </a:extLst>
+          </p:cNvPr>
+          <p:cNvSpPr txBox="1"/>
+          <p:nvPr/>
+        </p:nvSpPr>
+        <p:spPr>
+          <a:xfrm>
+            <a:off x="10323839" y="1012287"/>
+            <a:ext cx="889000" cy="261610"/>
+          </a:xfrm>
+          <a:prstGeom prst="rect">
+            <a:avLst/>
+          </a:prstGeom>
+          <a:noFill/>
+        </p:spPr>
+        <p:txBody>
+          <a:bodyPr wrap="square" rtlCol="0">
+            <a:spAutoFit/>
+          </a:bodyPr>
+          <a:lstStyle/>
+          <a:p>
+            <a:r>
+              <a:rPr lang="en-US" sz="1100" dirty="0"/>
+              <a:t>Billion</a:t>
+            </a:r>
+          </a:p>
+        </p:txBody>
+      </p:sp>
     </p:spTree>
     <p:extLst>
       <p:ext uri="{BB962C8B-B14F-4D97-AF65-F5344CB8AC3E}">
@@ -29854,7 +32172,7 @@
           </p:nvPr>
         </p:nvPicPr>
         <p:blipFill>
-          <a:blip r:embed="rId2"/>
+          <a:blip r:embed="rId3"/>
           <a:stretch>
             <a:fillRect/>
           </a:stretch>
@@ -30312,7 +32630,7 @@
           <p:nvPr/>
         </p:nvPicPr>
         <p:blipFill>
-          <a:blip r:embed="rId2"/>
+          <a:blip r:embed="rId3"/>
           <a:stretch>
             <a:fillRect/>
           </a:stretch>
@@ -30791,7 +33109,7 @@
           <p:nvPr/>
         </p:nvPicPr>
         <p:blipFill>
-          <a:blip r:embed="rId2"/>
+          <a:blip r:embed="rId3"/>
           <a:stretch>
             <a:fillRect/>
           </a:stretch>
@@ -31208,4 +33526,319 @@
     </a:ext>
   </a:extLst>
 </a:theme>
+</file>
+
+<file path=ppt/theme/theme2.xml><?xml version="1.0" encoding="utf-8"?>
+<a:theme xmlns:a="http://schemas.openxmlformats.org/drawingml/2006/main" name="Office Theme">
+  <a:themeElements>
+    <a:clrScheme name="Office">
+      <a:dk1>
+        <a:sysClr val="windowText" lastClr="000000"/>
+      </a:dk1>
+      <a:lt1>
+        <a:sysClr val="window" lastClr="FFFFFF"/>
+      </a:lt1>
+      <a:dk2>
+        <a:srgbClr val="0E2841"/>
+      </a:dk2>
+      <a:lt2>
+        <a:srgbClr val="E8E8E8"/>
+      </a:lt2>
+      <a:accent1>
+        <a:srgbClr val="156082"/>
+      </a:accent1>
+      <a:accent2>
+        <a:srgbClr val="E97132"/>
+      </a:accent2>
+      <a:accent3>
+        <a:srgbClr val="196B24"/>
+      </a:accent3>
+      <a:accent4>
+        <a:srgbClr val="0F9ED5"/>
+      </a:accent4>
+      <a:accent5>
+        <a:srgbClr val="A02B93"/>
+      </a:accent5>
+      <a:accent6>
+        <a:srgbClr val="4EA72E"/>
+      </a:accent6>
+      <a:hlink>
+        <a:srgbClr val="467886"/>
+      </a:hlink>
+      <a:folHlink>
+        <a:srgbClr val="96607D"/>
+      </a:folHlink>
+    </a:clrScheme>
+    <a:fontScheme name="Office">
+      <a:majorFont>
+        <a:latin typeface="Aptos Display" panose="02110004020202020204"/>
+        <a:ea typeface=""/>
+        <a:cs typeface=""/>
+        <a:font script="Jpan" typeface="游ゴシック Light"/>
+        <a:font script="Hang" typeface="맑은 고딕"/>
+        <a:font script="Hans" typeface="等线 Light"/>
+        <a:font script="Hant" typeface="新細明體"/>
+        <a:font script="Arab" typeface="Times New Roman"/>
+        <a:font script="Hebr" typeface="Times New Roman"/>
+        <a:font script="Thai" typeface="Angsana New"/>
+        <a:font script="Ethi" typeface="Nyala"/>
+        <a:font script="Beng" typeface="Vrinda"/>
+        <a:font script="Gujr" typeface="Shruti"/>
+        <a:font script="Khmr" typeface="MoolBoran"/>
+        <a:font script="Knda" typeface="Tunga"/>
+        <a:font script="Guru" typeface="Raavi"/>
+        <a:font script="Cans" typeface="Euphemia"/>
+        <a:font script="Cher" typeface="Plantagenet Cherokee"/>
+        <a:font script="Yiii" typeface="Microsoft Yi Baiti"/>
+        <a:font script="Tibt" typeface="Microsoft Himalaya"/>
+        <a:font script="Thaa" typeface="MV Boli"/>
+        <a:font script="Deva" typeface="Mangal"/>
+        <a:font script="Telu" typeface="Gautami"/>
+        <a:font script="Taml" typeface="Latha"/>
+        <a:font script="Syrc" typeface="Estrangelo Edessa"/>
+        <a:font script="Orya" typeface="Kalinga"/>
+        <a:font script="Mlym" typeface="Kartika"/>
+        <a:font script="Laoo" typeface="DokChampa"/>
+        <a:font script="Sinh" typeface="Iskoola Pota"/>
+        <a:font script="Mong" typeface="Mongolian Baiti"/>
+        <a:font script="Viet" typeface="Times New Roman"/>
+        <a:font script="Uigh" typeface="Microsoft Uighur"/>
+        <a:font script="Geor" typeface="Sylfaen"/>
+        <a:font script="Armn" typeface="Arial"/>
+        <a:font script="Bugi" typeface="Leelawadee UI"/>
+        <a:font script="Bopo" typeface="Microsoft JhengHei"/>
+        <a:font script="Java" typeface="Javanese Text"/>
+        <a:font script="Lisu" typeface="Segoe UI"/>
+        <a:font script="Mymr" typeface="Myanmar Text"/>
+        <a:font script="Nkoo" typeface="Ebrima"/>
+        <a:font script="Olck" typeface="Nirmala UI"/>
+        <a:font script="Osma" typeface="Ebrima"/>
+        <a:font script="Phag" typeface="Phagspa"/>
+        <a:font script="Syrn" typeface="Estrangelo Edessa"/>
+        <a:font script="Syrj" typeface="Estrangelo Edessa"/>
+        <a:font script="Syre" typeface="Estrangelo Edessa"/>
+        <a:font script="Sora" typeface="Nirmala UI"/>
+        <a:font script="Tale" typeface="Microsoft Tai Le"/>
+        <a:font script="Talu" typeface="Microsoft New Tai Lue"/>
+        <a:font script="Tfng" typeface="Ebrima"/>
+      </a:majorFont>
+      <a:minorFont>
+        <a:latin typeface="Aptos" panose="02110004020202020204"/>
+        <a:ea typeface=""/>
+        <a:cs typeface=""/>
+        <a:font script="Jpan" typeface="游ゴシック"/>
+        <a:font script="Hang" typeface="맑은 고딕"/>
+        <a:font script="Hans" typeface="等线"/>
+        <a:font script="Hant" typeface="新細明體"/>
+        <a:font script="Arab" typeface="Arial"/>
+        <a:font script="Hebr" typeface="Arial"/>
+        <a:font script="Thai" typeface="Cordia New"/>
+        <a:font script="Ethi" typeface="Nyala"/>
+        <a:font script="Beng" typeface="Vrinda"/>
+        <a:font script="Gujr" typeface="Shruti"/>
+        <a:font script="Khmr" typeface="DaunPenh"/>
+        <a:font script="Knda" typeface="Tunga"/>
+        <a:font script="Guru" typeface="Raavi"/>
+        <a:font script="Cans" typeface="Euphemia"/>
+        <a:font script="Cher" typeface="Plantagenet Cherokee"/>
+        <a:font script="Yiii" typeface="Microsoft Yi Baiti"/>
+        <a:font script="Tibt" typeface="Microsoft Himalaya"/>
+        <a:font script="Thaa" typeface="MV Boli"/>
+        <a:font script="Deva" typeface="Mangal"/>
+        <a:font script="Telu" typeface="Gautami"/>
+        <a:font script="Taml" typeface="Latha"/>
+        <a:font script="Syrc" typeface="Estrangelo Edessa"/>
+        <a:font script="Orya" typeface="Kalinga"/>
+        <a:font script="Mlym" typeface="Kartika"/>
+        <a:font script="Laoo" typeface="DokChampa"/>
+        <a:font script="Sinh" typeface="Iskoola Pota"/>
+        <a:font script="Mong" typeface="Mongolian Baiti"/>
+        <a:font script="Viet" typeface="Arial"/>
+        <a:font script="Uigh" typeface="Microsoft Uighur"/>
+        <a:font script="Geor" typeface="Sylfaen"/>
+        <a:font script="Armn" typeface="Arial"/>
+        <a:font script="Bugi" typeface="Leelawadee UI"/>
+        <a:font script="Bopo" typeface="Microsoft JhengHei"/>
+        <a:font script="Java" typeface="Javanese Text"/>
+        <a:font script="Lisu" typeface="Segoe UI"/>
+        <a:font script="Mymr" typeface="Myanmar Text"/>
+        <a:font script="Nkoo" typeface="Ebrima"/>
+        <a:font script="Olck" typeface="Nirmala UI"/>
+        <a:font script="Osma" typeface="Ebrima"/>
+        <a:font script="Phag" typeface="Phagspa"/>
+        <a:font script="Syrn" typeface="Estrangelo Edessa"/>
+        <a:font script="Syrj" typeface="Estrangelo Edessa"/>
+        <a:font script="Syre" typeface="Estrangelo Edessa"/>
+        <a:font script="Sora" typeface="Nirmala UI"/>
+        <a:font script="Tale" typeface="Microsoft Tai Le"/>
+        <a:font script="Talu" typeface="Microsoft New Tai Lue"/>
+        <a:font script="Tfng" typeface="Ebrima"/>
+      </a:minorFont>
+    </a:fontScheme>
+    <a:fmtScheme name="Office">
+      <a:fillStyleLst>
+        <a:solidFill>
+          <a:schemeClr val="phClr"/>
+        </a:solidFill>
+        <a:gradFill rotWithShape="1">
+          <a:gsLst>
+            <a:gs pos="0">
+              <a:schemeClr val="phClr">
+                <a:lumMod val="110000"/>
+                <a:satMod val="105000"/>
+                <a:tint val="67000"/>
+              </a:schemeClr>
+            </a:gs>
+            <a:gs pos="50000">
+              <a:schemeClr val="phClr">
+                <a:lumMod val="105000"/>
+                <a:satMod val="103000"/>
+                <a:tint val="73000"/>
+              </a:schemeClr>
+            </a:gs>
+            <a:gs pos="100000">
+              <a:schemeClr val="phClr">
+                <a:lumMod val="105000"/>
+                <a:satMod val="109000"/>
+                <a:tint val="81000"/>
+              </a:schemeClr>
+            </a:gs>
+          </a:gsLst>
+          <a:lin ang="5400000" scaled="0"/>
+        </a:gradFill>
+        <a:gradFill rotWithShape="1">
+          <a:gsLst>
+            <a:gs pos="0">
+              <a:schemeClr val="phClr">
+                <a:satMod val="103000"/>
+                <a:lumMod val="102000"/>
+                <a:tint val="94000"/>
+              </a:schemeClr>
+            </a:gs>
+            <a:gs pos="50000">
+              <a:schemeClr val="phClr">
+                <a:satMod val="110000"/>
+                <a:lumMod val="100000"/>
+                <a:shade val="100000"/>
+              </a:schemeClr>
+            </a:gs>
+            <a:gs pos="100000">
+              <a:schemeClr val="phClr">
+                <a:lumMod val="99000"/>
+                <a:satMod val="120000"/>
+                <a:shade val="78000"/>
+              </a:schemeClr>
+            </a:gs>
+          </a:gsLst>
+          <a:lin ang="5400000" scaled="0"/>
+        </a:gradFill>
+      </a:fillStyleLst>
+      <a:lnStyleLst>
+        <a:ln w="12700" cap="flat" cmpd="sng" algn="ctr">
+          <a:solidFill>
+            <a:schemeClr val="phClr"/>
+          </a:solidFill>
+          <a:prstDash val="solid"/>
+          <a:miter lim="800000"/>
+        </a:ln>
+        <a:ln w="19050" cap="flat" cmpd="sng" algn="ctr">
+          <a:solidFill>
+            <a:schemeClr val="phClr"/>
+          </a:solidFill>
+          <a:prstDash val="solid"/>
+          <a:miter lim="800000"/>
+        </a:ln>
+        <a:ln w="25400" cap="flat" cmpd="sng" algn="ctr">
+          <a:solidFill>
+            <a:schemeClr val="phClr"/>
+          </a:solidFill>
+          <a:prstDash val="solid"/>
+          <a:miter lim="800000"/>
+        </a:ln>
+      </a:lnStyleLst>
+      <a:effectStyleLst>
+        <a:effectStyle>
+          <a:effectLst/>
+        </a:effectStyle>
+        <a:effectStyle>
+          <a:effectLst/>
+        </a:effectStyle>
+        <a:effectStyle>
+          <a:effectLst>
+            <a:outerShdw blurRad="57150" dist="19050" dir="5400000" algn="ctr" rotWithShape="0">
+              <a:srgbClr val="000000">
+                <a:alpha val="63000"/>
+              </a:srgbClr>
+            </a:outerShdw>
+          </a:effectLst>
+        </a:effectStyle>
+      </a:effectStyleLst>
+      <a:bgFillStyleLst>
+        <a:solidFill>
+          <a:schemeClr val="phClr"/>
+        </a:solidFill>
+        <a:solidFill>
+          <a:schemeClr val="phClr">
+            <a:tint val="95000"/>
+            <a:satMod val="170000"/>
+          </a:schemeClr>
+        </a:solidFill>
+        <a:gradFill rotWithShape="1">
+          <a:gsLst>
+            <a:gs pos="0">
+              <a:schemeClr val="phClr">
+                <a:tint val="93000"/>
+                <a:satMod val="150000"/>
+                <a:shade val="98000"/>
+                <a:lumMod val="102000"/>
+              </a:schemeClr>
+            </a:gs>
+            <a:gs pos="50000">
+              <a:schemeClr val="phClr">
+                <a:tint val="98000"/>
+                <a:satMod val="130000"/>
+                <a:shade val="90000"/>
+                <a:lumMod val="103000"/>
+              </a:schemeClr>
+            </a:gs>
+            <a:gs pos="100000">
+              <a:schemeClr val="phClr">
+                <a:shade val="63000"/>
+                <a:satMod val="120000"/>
+              </a:schemeClr>
+            </a:gs>
+          </a:gsLst>
+          <a:lin ang="5400000" scaled="0"/>
+        </a:gradFill>
+      </a:bgFillStyleLst>
+    </a:fmtScheme>
+  </a:themeElements>
+  <a:objectDefaults>
+    <a:lnDef>
+      <a:spPr/>
+      <a:bodyPr/>
+      <a:lstStyle/>
+      <a:style>
+        <a:lnRef idx="2">
+          <a:schemeClr val="accent1"/>
+        </a:lnRef>
+        <a:fillRef idx="0">
+          <a:schemeClr val="accent1"/>
+        </a:fillRef>
+        <a:effectRef idx="1">
+          <a:schemeClr val="accent1"/>
+        </a:effectRef>
+        <a:fontRef idx="minor">
+          <a:schemeClr val="tx1"/>
+        </a:fontRef>
+      </a:style>
+    </a:lnDef>
+  </a:objectDefaults>
+  <a:extraClrSchemeLst/>
+  <a:extLst>
+    <a:ext uri="{05A4C25C-085E-4340-85A3-A5531E510DB2}">
+      <thm15:themeFamily xmlns:thm15="http://schemas.microsoft.com/office/thememl/2012/main" name="Office Theme" id="{2E142A2C-CD16-42D6-873A-C26D2A0506FA}" vid="{1BDDFF52-6CD6-40A5-AB3C-68EB2F1E4D0A}"/>
+    </a:ext>
+  </a:extLst>
+</a:theme>
 </file>
</xml_diff>